<commit_message>
docs: add a plain-language "MIP in plain words" slide
Add one slide to both decks (Beamer slides.tex + python-pptx build_slides.py)
that explains the Mixed-Integer Program and every equation in everyday language,
avoiding jargon. A two-column table maps each line of the formulation to a plain
gloss: the binary variable is an on/off switch per question per paper; the
objective turns ON the switches that add up to the best quality total; the "="
lines take exactly the wanted number per chapter / difficulty / type; the "<= 1"
lines stop versions and near-twins from overlapping. Closes with "= means a
promise kept exactly; <= 1 means a limit that stops overlap".

Rebuilt slides.pdf (22 pages) and quizgen_slides.pptx (12 slides).

Co-Authored-By: Claude Opus 4.8 <noreply@anthropic.com>
Claude-Session: https://claude.ai/code/session_014BYbxGKchjKwVuqREyPdV9
</commit_message>
<xml_diff>
--- a/docs/quizgen_slides.pptx
+++ b/docs/quizgen_slides.pptx
@@ -16,6 +16,7 @@
     <p:sldId id="264" r:id="rId15"/>
     <p:sldId id="265" r:id="rId16"/>
     <p:sldId id="266" r:id="rId17"/>
+    <p:sldId id="267" r:id="rId18"/>
   </p:sldIdLst>
   <p:sldSz cx="12191695" cy="6858000" type="screen4x3"/>
   <p:notesSz cx="6858000" cy="9144000"/>
@@ -3667,7 +3668,7 @@
                 </a:solidFill>
                 <a:latin typeface="Calibri"/>
               </a:rPr>
-              <a:t>Where each technique comes from</a:t>
+              <a:t>Using it</a:t>
             </a:r>
           </a:p>
         </p:txBody>
@@ -3737,7 +3738,7 @@
                 </a:solidFill>
                 <a:latin typeface="Calibri"/>
               </a:rPr>
-              <a:t>TECHNIQUE → SOURCE LINEAGE</a:t>
+              <a:t>python -m quizgen</a:t>
             </a:r>
           </a:p>
         </p:txBody>
@@ -3893,16 +3894,51 @@
       </p:sp>
       <p:sp>
         <p:nvSpPr>
-          <p:cNvPr id="11" name="Rounded Rectangle 10"/>
+          <p:cNvPr id="11" name="TextBox 10"/>
+          <p:cNvSpPr txBox="1"/>
+          <p:nvPr/>
+        </p:nvSpPr>
+        <p:spPr>
+          <a:xfrm>
+            <a:off x="640080" y="1188720"/>
+            <a:ext cx="10972800" cy="365760"/>
+          </a:xfrm>
+          <a:prstGeom prst="rect">
+            <a:avLst/>
+          </a:prstGeom>
+          <a:noFill/>
+        </p:spPr>
+        <p:txBody>
+          <a:bodyPr wrap="square" anchor="t">
+            <a:spAutoFit/>
+          </a:bodyPr>
+          <a:lstStyle/>
+          <a:p>
+            <a:pPr algn="l"/>
+            <a:r>
+              <a:rPr sz="1600" b="1" i="0">
+                <a:solidFill>
+                  <a:srgbClr val="222222"/>
+                </a:solidFill>
+                <a:latin typeface="Calibri"/>
+              </a:rPr>
+              <a:t>Pure command line (no YAML):</a:t>
+            </a:r>
+          </a:p>
+        </p:txBody>
+      </p:sp>
+      <p:sp>
+        <p:nvSpPr>
+          <p:cNvPr id="12" name="Rectangle 11"/>
           <p:cNvSpPr/>
           <p:nvPr/>
         </p:nvSpPr>
         <p:spPr>
           <a:xfrm>
-            <a:off x="640080" y="1280160"/>
-            <a:ext cx="5120640" cy="502920"/>
-          </a:xfrm>
-          <a:prstGeom prst="roundRect">
+            <a:off x="640080" y="1600200"/>
+            <a:ext cx="10972800" cy="1371600"/>
+          </a:xfrm>
+          <a:prstGeom prst="rect">
             <a:avLst/>
           </a:prstGeom>
           <a:solidFill>
@@ -3935,29 +3971,112 @@
           <a:p>
             <a:pPr algn="ctr"/>
             <a:r>
-              <a:rPr sz="1400" b="1" i="0">
+              <a:rPr sz="1300" b="0" i="0">
                 <a:solidFill>
                   <a:srgbClr val="FFFFFF"/>
                 </a:solidFill>
-                <a:latin typeface="Calibri"/>
-              </a:rPr>
-              <a:t>Implemented in code</a:t>
-            </a:r>
-          </a:p>
-        </p:txBody>
-      </p:sp>
-      <p:sp>
-        <p:nvSpPr>
-          <p:cNvPr id="12" name="Rounded Rectangle 11"/>
+                <a:latin typeface="Consolas"/>
+              </a:rPr>
+              <a:t>python -m quizgen --pool questions.json \</a:t>
+            </a:r>
+          </a:p>
+          <a:p>
+            <a:pPr algn="ctr"/>
+            <a:r>
+              <a:rPr sz="1300" b="0" i="0">
+                <a:solidFill>
+                  <a:srgbClr val="FFFFFF"/>
+                </a:solidFill>
+                <a:latin typeface="Consolas"/>
+              </a:rPr>
+              <a:t>    --total 20 --chapters 1:10,2:6,3:4 \</a:t>
+            </a:r>
+          </a:p>
+          <a:p>
+            <a:pPr algn="ctr"/>
+            <a:r>
+              <a:rPr sz="1300" b="0" i="0">
+                <a:solidFill>
+                  <a:srgbClr val="FFFFFF"/>
+                </a:solidFill>
+                <a:latin typeface="Consolas"/>
+              </a:rPr>
+              <a:t>    --difficulty 0.4,0.4,0.2 \</a:t>
+            </a:r>
+          </a:p>
+          <a:p>
+            <a:pPr algn="ctr"/>
+            <a:r>
+              <a:rPr sz="1300" b="0" i="0">
+                <a:solidFill>
+                  <a:srgbClr val="FFFFFF"/>
+                </a:solidFill>
+                <a:latin typeface="Consolas"/>
+              </a:rPr>
+              <a:t>    --qtype-mix mcq:0.4,true_false:0.2,short_answer:0.2,cloze:0.2 \</a:t>
+            </a:r>
+          </a:p>
+          <a:p>
+            <a:pPr algn="ctr"/>
+            <a:r>
+              <a:rPr sz="1300" b="0" i="0">
+                <a:solidFill>
+                  <a:srgbClr val="FFFFFF"/>
+                </a:solidFill>
+                <a:latin typeface="Consolas"/>
+              </a:rPr>
+              <a:t>    --versions 2 --selector mip</a:t>
+            </a:r>
+          </a:p>
+        </p:txBody>
+      </p:sp>
+      <p:sp>
+        <p:nvSpPr>
+          <p:cNvPr id="13" name="TextBox 12"/>
+          <p:cNvSpPr txBox="1"/>
+          <p:nvPr/>
+        </p:nvSpPr>
+        <p:spPr>
+          <a:xfrm>
+            <a:off x="640080" y="3246120"/>
+            <a:ext cx="10972800" cy="365760"/>
+          </a:xfrm>
+          <a:prstGeom prst="rect">
+            <a:avLst/>
+          </a:prstGeom>
+          <a:noFill/>
+        </p:spPr>
+        <p:txBody>
+          <a:bodyPr wrap="square" anchor="t">
+            <a:spAutoFit/>
+          </a:bodyPr>
+          <a:lstStyle/>
+          <a:p>
+            <a:pPr algn="l"/>
+            <a:r>
+              <a:rPr sz="1600" b="1" i="0">
+                <a:solidFill>
+                  <a:srgbClr val="222222"/>
+                </a:solidFill>
+                <a:latin typeface="Calibri"/>
+              </a:rPr>
+              <a:t>Blueprint file + dedup + per-version validation report:</a:t>
+            </a:r>
+          </a:p>
+        </p:txBody>
+      </p:sp>
+      <p:sp>
+        <p:nvSpPr>
+          <p:cNvPr id="14" name="Rectangle 13"/>
           <p:cNvSpPr/>
           <p:nvPr/>
         </p:nvSpPr>
         <p:spPr>
           <a:xfrm>
-            <a:off x="5852160" y="1280160"/>
-            <a:ext cx="5760720" cy="502920"/>
-          </a:xfrm>
-          <a:prstGeom prst="roundRect">
+            <a:off x="640080" y="3657600"/>
+            <a:ext cx="10972800" cy="914400"/>
+          </a:xfrm>
+          <a:prstGeom prst="rect">
             <a:avLst/>
           </a:prstGeom>
           <a:solidFill>
@@ -3990,797 +4109,39 @@
           <a:p>
             <a:pPr algn="ctr"/>
             <a:r>
-              <a:rPr sz="1400" b="1" i="0">
+              <a:rPr sz="1400" b="0" i="0">
                 <a:solidFill>
                   <a:srgbClr val="FFFFFF"/>
                 </a:solidFill>
-                <a:latin typeface="Calibri"/>
-              </a:rPr>
-              <a:t>Source lineage</a:t>
-            </a:r>
-          </a:p>
-        </p:txBody>
-      </p:sp>
-      <p:sp>
-        <p:nvSpPr>
-          <p:cNvPr id="13" name="Rectangle 12"/>
-          <p:cNvSpPr/>
-          <p:nvPr/>
-        </p:nvSpPr>
-        <p:spPr>
-          <a:xfrm>
-            <a:off x="640080" y="1783080"/>
-            <a:ext cx="5120640" cy="502920"/>
-          </a:xfrm>
-          <a:prstGeom prst="rect">
-            <a:avLst/>
-          </a:prstGeom>
-          <a:solidFill>
-            <a:srgbClr val="F0F0F2"/>
-          </a:solidFill>
-          <a:ln w="15875">
-            <a:solidFill>
-              <a:srgbClr val="636363"/>
-            </a:solidFill>
-          </a:ln>
-          <a:effectLst/>
-        </p:spPr>
-        <p:style>
-          <a:lnRef idx="1">
-            <a:schemeClr val="accent1"/>
-          </a:lnRef>
-          <a:fillRef idx="3">
-            <a:schemeClr val="accent1"/>
-          </a:fillRef>
-          <a:effectRef idx="2">
-            <a:schemeClr val="accent1"/>
-          </a:effectRef>
-          <a:fontRef idx="minor">
-            <a:schemeClr val="lt1"/>
-          </a:fontRef>
-        </p:style>
-        <p:txBody>
-          <a:bodyPr rtlCol="0" anchor="ctr" wrap="square" lIns="45720" rIns="45720" tIns="27432" bIns="27432"/>
-          <a:lstStyle/>
-          <a:p>
-            <a:pPr algn="ctr"/>
-            <a:r>
-              <a:rPr sz="1200" b="0" i="0">
-                <a:solidFill>
-                  <a:srgbClr val="222222"/>
-                </a:solidFill>
-                <a:latin typeface="Calibri"/>
-              </a:rPr>
-              <a:t>Test assembly as 0–1 MIP</a:t>
-            </a:r>
-          </a:p>
-        </p:txBody>
-      </p:sp>
-      <p:sp>
-        <p:nvSpPr>
-          <p:cNvPr id="14" name="Rectangle 13"/>
-          <p:cNvSpPr/>
-          <p:nvPr/>
-        </p:nvSpPr>
-        <p:spPr>
-          <a:xfrm>
-            <a:off x="5852160" y="1783080"/>
-            <a:ext cx="5760720" cy="502920"/>
-          </a:xfrm>
-          <a:prstGeom prst="rect">
-            <a:avLst/>
-          </a:prstGeom>
-          <a:solidFill>
-            <a:srgbClr val="F0F0F2"/>
-          </a:solidFill>
-          <a:ln w="15875">
-            <a:solidFill>
-              <a:srgbClr val="636363"/>
-            </a:solidFill>
-          </a:ln>
-          <a:effectLst/>
-        </p:spPr>
-        <p:style>
-          <a:lnRef idx="1">
-            <a:schemeClr val="accent1"/>
-          </a:lnRef>
-          <a:fillRef idx="3">
-            <a:schemeClr val="accent1"/>
-          </a:fillRef>
-          <a:effectRef idx="2">
-            <a:schemeClr val="accent1"/>
-          </a:effectRef>
-          <a:fontRef idx="minor">
-            <a:schemeClr val="lt1"/>
-          </a:fontRef>
-        </p:style>
-        <p:txBody>
-          <a:bodyPr rtlCol="0" anchor="ctr" wrap="square" lIns="45720" rIns="45720" tIns="27432" bIns="27432"/>
-          <a:lstStyle/>
-          <a:p>
-            <a:pPr algn="ctr"/>
-            <a:r>
-              <a:rPr sz="1200" b="0" i="0">
-                <a:solidFill>
-                  <a:srgbClr val="222222"/>
-                </a:solidFill>
-                <a:latin typeface="Calibri"/>
-              </a:rPr>
-              <a:t>van der Linden 2005 — optimal test design</a:t>
-            </a:r>
-          </a:p>
-        </p:txBody>
-      </p:sp>
-      <p:sp>
-        <p:nvSpPr>
-          <p:cNvPr id="15" name="Rectangle 14"/>
-          <p:cNvSpPr/>
-          <p:nvPr/>
-        </p:nvSpPr>
-        <p:spPr>
-          <a:xfrm>
-            <a:off x="640080" y="2286000"/>
-            <a:ext cx="5120640" cy="502920"/>
-          </a:xfrm>
-          <a:prstGeom prst="rect">
-            <a:avLst/>
-          </a:prstGeom>
-          <a:solidFill>
-            <a:srgbClr val="FFFFFF"/>
-          </a:solidFill>
-          <a:ln w="15875">
-            <a:solidFill>
-              <a:srgbClr val="636363"/>
-            </a:solidFill>
-          </a:ln>
-          <a:effectLst/>
-        </p:spPr>
-        <p:style>
-          <a:lnRef idx="1">
-            <a:schemeClr val="accent1"/>
-          </a:lnRef>
-          <a:fillRef idx="3">
-            <a:schemeClr val="accent1"/>
-          </a:fillRef>
-          <a:effectRef idx="2">
-            <a:schemeClr val="accent1"/>
-          </a:effectRef>
-          <a:fontRef idx="minor">
-            <a:schemeClr val="lt1"/>
-          </a:fontRef>
-        </p:style>
-        <p:txBody>
-          <a:bodyPr rtlCol="0" anchor="ctr" wrap="square" lIns="45720" rIns="45720" tIns="27432" bIns="27432"/>
-          <a:lstStyle/>
-          <a:p>
-            <a:pPr algn="ctr"/>
-            <a:r>
-              <a:rPr sz="1200" b="0" i="0">
-                <a:solidFill>
-                  <a:srgbClr val="222222"/>
-                </a:solidFill>
-                <a:latin typeface="Calibri"/>
-              </a:rPr>
-              <a:t>Quality-weighted selection</a:t>
-            </a:r>
-          </a:p>
-        </p:txBody>
-      </p:sp>
-      <p:sp>
-        <p:nvSpPr>
-          <p:cNvPr id="16" name="Rectangle 15"/>
-          <p:cNvSpPr/>
-          <p:nvPr/>
-        </p:nvSpPr>
-        <p:spPr>
-          <a:xfrm>
-            <a:off x="5852160" y="2286000"/>
-            <a:ext cx="5760720" cy="502920"/>
-          </a:xfrm>
-          <a:prstGeom prst="rect">
-            <a:avLst/>
-          </a:prstGeom>
-          <a:solidFill>
-            <a:srgbClr val="FFFFFF"/>
-          </a:solidFill>
-          <a:ln w="15875">
-            <a:solidFill>
-              <a:srgbClr val="636363"/>
-            </a:solidFill>
-          </a:ln>
-          <a:effectLst/>
-        </p:spPr>
-        <p:style>
-          <a:lnRef idx="1">
-            <a:schemeClr val="accent1"/>
-          </a:lnRef>
-          <a:fillRef idx="3">
-            <a:schemeClr val="accent1"/>
-          </a:fillRef>
-          <a:effectRef idx="2">
-            <a:schemeClr val="accent1"/>
-          </a:effectRef>
-          <a:fontRef idx="minor">
-            <a:schemeClr val="lt1"/>
-          </a:fontRef>
-        </p:style>
-        <p:txBody>
-          <a:bodyPr rtlCol="0" anchor="ctr" wrap="square" lIns="45720" rIns="45720" tIns="27432" bIns="27432"/>
-          <a:lstStyle/>
-          <a:p>
-            <a:pPr algn="ctr"/>
-            <a:r>
-              <a:rPr sz="1200" b="0" i="0">
-                <a:solidFill>
-                  <a:srgbClr val="222222"/>
-                </a:solidFill>
-                <a:latin typeface="Calibri"/>
-              </a:rPr>
-              <a:t>van der Linden 2005 (objective in ATA)</a:t>
-            </a:r>
-          </a:p>
-        </p:txBody>
-      </p:sp>
-      <p:sp>
-        <p:nvSpPr>
-          <p:cNvPr id="17" name="Rectangle 16"/>
-          <p:cNvSpPr/>
-          <p:nvPr/>
-        </p:nvSpPr>
-        <p:spPr>
-          <a:xfrm>
-            <a:off x="640080" y="2788920"/>
-            <a:ext cx="5120640" cy="502920"/>
-          </a:xfrm>
-          <a:prstGeom prst="rect">
-            <a:avLst/>
-          </a:prstGeom>
-          <a:solidFill>
-            <a:srgbClr val="F0F0F2"/>
-          </a:solidFill>
-          <a:ln w="15875">
-            <a:solidFill>
-              <a:srgbClr val="636363"/>
-            </a:solidFill>
-          </a:ln>
-          <a:effectLst/>
-        </p:spPr>
-        <p:style>
-          <a:lnRef idx="1">
-            <a:schemeClr val="accent1"/>
-          </a:lnRef>
-          <a:fillRef idx="3">
-            <a:schemeClr val="accent1"/>
-          </a:fillRef>
-          <a:effectRef idx="2">
-            <a:schemeClr val="accent1"/>
-          </a:effectRef>
-          <a:fontRef idx="minor">
-            <a:schemeClr val="lt1"/>
-          </a:fontRef>
-        </p:style>
-        <p:txBody>
-          <a:bodyPr rtlCol="0" anchor="ctr" wrap="square" lIns="45720" rIns="45720" tIns="27432" bIns="27432"/>
-          <a:lstStyle/>
-          <a:p>
-            <a:pPr algn="ctr"/>
-            <a:r>
-              <a:rPr sz="1200" b="0" i="0">
-                <a:solidFill>
-                  <a:srgbClr val="222222"/>
-                </a:solidFill>
-                <a:latin typeface="Calibri"/>
-              </a:rPr>
-              <a:t>Test blueprint / type &amp; difficulty mix</a:t>
-            </a:r>
-          </a:p>
-        </p:txBody>
-      </p:sp>
-      <p:sp>
-        <p:nvSpPr>
-          <p:cNvPr id="18" name="Rectangle 17"/>
-          <p:cNvSpPr/>
-          <p:nvPr/>
-        </p:nvSpPr>
-        <p:spPr>
-          <a:xfrm>
-            <a:off x="5852160" y="2788920"/>
-            <a:ext cx="5760720" cy="502920"/>
-          </a:xfrm>
-          <a:prstGeom prst="rect">
-            <a:avLst/>
-          </a:prstGeom>
-          <a:solidFill>
-            <a:srgbClr val="F0F0F2"/>
-          </a:solidFill>
-          <a:ln w="15875">
-            <a:solidFill>
-              <a:srgbClr val="636363"/>
-            </a:solidFill>
-          </a:ln>
-          <a:effectLst/>
-        </p:spPr>
-        <p:style>
-          <a:lnRef idx="1">
-            <a:schemeClr val="accent1"/>
-          </a:lnRef>
-          <a:fillRef idx="3">
-            <a:schemeClr val="accent1"/>
-          </a:fillRef>
-          <a:effectRef idx="2">
-            <a:schemeClr val="accent1"/>
-          </a:effectRef>
-          <a:fontRef idx="minor">
-            <a:schemeClr val="lt1"/>
-          </a:fontRef>
-        </p:style>
-        <p:txBody>
-          <a:bodyPr rtlCol="0" anchor="ctr" wrap="square" lIns="45720" rIns="45720" tIns="27432" bIns="27432"/>
-          <a:lstStyle/>
-          <a:p>
-            <a:pPr algn="ctr"/>
-            <a:r>
-              <a:rPr sz="1200" b="0" i="0">
-                <a:solidFill>
-                  <a:srgbClr val="222222"/>
-                </a:solidFill>
-                <a:latin typeface="Calibri"/>
-              </a:rPr>
-              <a:t>classical table-of-specifications design</a:t>
-            </a:r>
-          </a:p>
-        </p:txBody>
-      </p:sp>
-      <p:sp>
-        <p:nvSpPr>
-          <p:cNvPr id="19" name="Rectangle 18"/>
-          <p:cNvSpPr/>
-          <p:nvPr/>
-        </p:nvSpPr>
-        <p:spPr>
-          <a:xfrm>
-            <a:off x="640080" y="3291840"/>
-            <a:ext cx="5120640" cy="502920"/>
-          </a:xfrm>
-          <a:prstGeom prst="rect">
-            <a:avLst/>
-          </a:prstGeom>
-          <a:solidFill>
-            <a:srgbClr val="FFFFFF"/>
-          </a:solidFill>
-          <a:ln w="15875">
-            <a:solidFill>
-              <a:srgbClr val="636363"/>
-            </a:solidFill>
-          </a:ln>
-          <a:effectLst/>
-        </p:spPr>
-        <p:style>
-          <a:lnRef idx="1">
-            <a:schemeClr val="accent1"/>
-          </a:lnRef>
-          <a:fillRef idx="3">
-            <a:schemeClr val="accent1"/>
-          </a:fillRef>
-          <a:effectRef idx="2">
-            <a:schemeClr val="accent1"/>
-          </a:effectRef>
-          <a:fontRef idx="minor">
-            <a:schemeClr val="lt1"/>
-          </a:fontRef>
-        </p:style>
-        <p:txBody>
-          <a:bodyPr rtlCol="0" anchor="ctr" wrap="square" lIns="45720" rIns="45720" tIns="27432" bIns="27432"/>
-          <a:lstStyle/>
-          <a:p>
-            <a:pPr algn="ctr"/>
-            <a:r>
-              <a:rPr sz="1200" b="0" i="0">
-                <a:solidFill>
-                  <a:srgbClr val="222222"/>
-                </a:solidFill>
-                <a:latin typeface="Calibri"/>
-              </a:rPr>
-              <a:t>Bloom-level metadata</a:t>
-            </a:r>
-          </a:p>
-        </p:txBody>
-      </p:sp>
-      <p:sp>
-        <p:nvSpPr>
-          <p:cNvPr id="20" name="Rectangle 19"/>
-          <p:cNvSpPr/>
-          <p:nvPr/>
-        </p:nvSpPr>
-        <p:spPr>
-          <a:xfrm>
-            <a:off x="5852160" y="3291840"/>
-            <a:ext cx="5760720" cy="502920"/>
-          </a:xfrm>
-          <a:prstGeom prst="rect">
-            <a:avLst/>
-          </a:prstGeom>
-          <a:solidFill>
-            <a:srgbClr val="FFFFFF"/>
-          </a:solidFill>
-          <a:ln w="15875">
-            <a:solidFill>
-              <a:srgbClr val="636363"/>
-            </a:solidFill>
-          </a:ln>
-          <a:effectLst/>
-        </p:spPr>
-        <p:style>
-          <a:lnRef idx="1">
-            <a:schemeClr val="accent1"/>
-          </a:lnRef>
-          <a:fillRef idx="3">
-            <a:schemeClr val="accent1"/>
-          </a:fillRef>
-          <a:effectRef idx="2">
-            <a:schemeClr val="accent1"/>
-          </a:effectRef>
-          <a:fontRef idx="minor">
-            <a:schemeClr val="lt1"/>
-          </a:fontRef>
-        </p:style>
-        <p:txBody>
-          <a:bodyPr rtlCol="0" anchor="ctr" wrap="square" lIns="45720" rIns="45720" tIns="27432" bIns="27432"/>
-          <a:lstStyle/>
-          <a:p>
-            <a:pPr algn="ctr"/>
-            <a:r>
-              <a:rPr sz="1200" b="0" i="0">
-                <a:solidFill>
-                  <a:srgbClr val="222222"/>
-                </a:solidFill>
-                <a:latin typeface="Calibri"/>
-              </a:rPr>
-              <a:t>Anderson &amp; Krathwohl 2001 (revised Bloom)</a:t>
-            </a:r>
-          </a:p>
-        </p:txBody>
-      </p:sp>
-      <p:sp>
-        <p:nvSpPr>
-          <p:cNvPr id="21" name="Rectangle 20"/>
-          <p:cNvSpPr/>
-          <p:nvPr/>
-        </p:nvSpPr>
-        <p:spPr>
-          <a:xfrm>
-            <a:off x="640080" y="3794760"/>
-            <a:ext cx="5120640" cy="502920"/>
-          </a:xfrm>
-          <a:prstGeom prst="rect">
-            <a:avLst/>
-          </a:prstGeom>
-          <a:solidFill>
-            <a:srgbClr val="F0F0F2"/>
-          </a:solidFill>
-          <a:ln w="15875">
-            <a:solidFill>
-              <a:srgbClr val="636363"/>
-            </a:solidFill>
-          </a:ln>
-          <a:effectLst/>
-        </p:spPr>
-        <p:style>
-          <a:lnRef idx="1">
-            <a:schemeClr val="accent1"/>
-          </a:lnRef>
-          <a:fillRef idx="3">
-            <a:schemeClr val="accent1"/>
-          </a:fillRef>
-          <a:effectRef idx="2">
-            <a:schemeClr val="accent1"/>
-          </a:effectRef>
-          <a:fontRef idx="minor">
-            <a:schemeClr val="lt1"/>
-          </a:fontRef>
-        </p:style>
-        <p:txBody>
-          <a:bodyPr rtlCol="0" anchor="ctr" wrap="square" lIns="45720" rIns="45720" tIns="27432" bIns="27432"/>
-          <a:lstStyle/>
-          <a:p>
-            <a:pPr algn="ctr"/>
-            <a:r>
-              <a:rPr sz="1200" b="0" i="0">
-                <a:solidFill>
-                  <a:srgbClr val="222222"/>
-                </a:solidFill>
-                <a:latin typeface="Calibri"/>
-              </a:rPr>
-              <a:t>Semantic dedup (embeddings)</a:t>
-            </a:r>
-          </a:p>
-        </p:txBody>
-      </p:sp>
-      <p:sp>
-        <p:nvSpPr>
-          <p:cNvPr id="22" name="Rectangle 21"/>
-          <p:cNvSpPr/>
-          <p:nvPr/>
-        </p:nvSpPr>
-        <p:spPr>
-          <a:xfrm>
-            <a:off x="5852160" y="3794760"/>
-            <a:ext cx="5760720" cy="502920"/>
-          </a:xfrm>
-          <a:prstGeom prst="rect">
-            <a:avLst/>
-          </a:prstGeom>
-          <a:solidFill>
-            <a:srgbClr val="F0F0F2"/>
-          </a:solidFill>
-          <a:ln w="15875">
-            <a:solidFill>
-              <a:srgbClr val="636363"/>
-            </a:solidFill>
-          </a:ln>
-          <a:effectLst/>
-        </p:spPr>
-        <p:style>
-          <a:lnRef idx="1">
-            <a:schemeClr val="accent1"/>
-          </a:lnRef>
-          <a:fillRef idx="3">
-            <a:schemeClr val="accent1"/>
-          </a:fillRef>
-          <a:effectRef idx="2">
-            <a:schemeClr val="accent1"/>
-          </a:effectRef>
-          <a:fontRef idx="minor">
-            <a:schemeClr val="lt1"/>
-          </a:fontRef>
-        </p:style>
-        <p:txBody>
-          <a:bodyPr rtlCol="0" anchor="ctr" wrap="square" lIns="45720" rIns="45720" tIns="27432" bIns="27432"/>
-          <a:lstStyle/>
-          <a:p>
-            <a:pPr algn="ctr"/>
-            <a:r>
-              <a:rPr sz="1200" b="0" i="0">
-                <a:solidFill>
-                  <a:srgbClr val="222222"/>
-                </a:solidFill>
-                <a:latin typeface="Calibri"/>
-              </a:rPr>
-              <a:t>Sentence-BERT (Reimers &amp; Gurevych 2019)</a:t>
-            </a:r>
-          </a:p>
-        </p:txBody>
-      </p:sp>
-      <p:sp>
-        <p:nvSpPr>
-          <p:cNvPr id="23" name="Rectangle 22"/>
-          <p:cNvSpPr/>
-          <p:nvPr/>
-        </p:nvSpPr>
-        <p:spPr>
-          <a:xfrm>
-            <a:off x="640080" y="4297680"/>
-            <a:ext cx="5120640" cy="502920"/>
-          </a:xfrm>
-          <a:prstGeom prst="rect">
-            <a:avLst/>
-          </a:prstGeom>
-          <a:solidFill>
-            <a:srgbClr val="FFFFFF"/>
-          </a:solidFill>
-          <a:ln w="15875">
-            <a:solidFill>
-              <a:srgbClr val="636363"/>
-            </a:solidFill>
-          </a:ln>
-          <a:effectLst/>
-        </p:spPr>
-        <p:style>
-          <a:lnRef idx="1">
-            <a:schemeClr val="accent1"/>
-          </a:lnRef>
-          <a:fillRef idx="3">
-            <a:schemeClr val="accent1"/>
-          </a:fillRef>
-          <a:effectRef idx="2">
-            <a:schemeClr val="accent1"/>
-          </a:effectRef>
-          <a:fontRef idx="minor">
-            <a:schemeClr val="lt1"/>
-          </a:fontRef>
-        </p:style>
-        <p:txBody>
-          <a:bodyPr rtlCol="0" anchor="ctr" wrap="square" lIns="45720" rIns="45720" tIns="27432" bIns="27432"/>
-          <a:lstStyle/>
-          <a:p>
-            <a:pPr algn="ctr"/>
-            <a:r>
-              <a:rPr sz="1200" b="0" i="0">
-                <a:solidFill>
-                  <a:srgbClr val="222222"/>
-                </a:solidFill>
-                <a:latin typeface="Calibri"/>
-              </a:rPr>
-              <a:t>Largest-remainder counts</a:t>
-            </a:r>
-          </a:p>
-        </p:txBody>
-      </p:sp>
-      <p:sp>
-        <p:nvSpPr>
-          <p:cNvPr id="24" name="Rectangle 23"/>
-          <p:cNvSpPr/>
-          <p:nvPr/>
-        </p:nvSpPr>
-        <p:spPr>
-          <a:xfrm>
-            <a:off x="5852160" y="4297680"/>
-            <a:ext cx="5760720" cy="502920"/>
-          </a:xfrm>
-          <a:prstGeom prst="rect">
-            <a:avLst/>
-          </a:prstGeom>
-          <a:solidFill>
-            <a:srgbClr val="FFFFFF"/>
-          </a:solidFill>
-          <a:ln w="15875">
-            <a:solidFill>
-              <a:srgbClr val="636363"/>
-            </a:solidFill>
-          </a:ln>
-          <a:effectLst/>
-        </p:spPr>
-        <p:style>
-          <a:lnRef idx="1">
-            <a:schemeClr val="accent1"/>
-          </a:lnRef>
-          <a:fillRef idx="3">
-            <a:schemeClr val="accent1"/>
-          </a:fillRef>
-          <a:effectRef idx="2">
-            <a:schemeClr val="accent1"/>
-          </a:effectRef>
-          <a:fontRef idx="minor">
-            <a:schemeClr val="lt1"/>
-          </a:fontRef>
-        </p:style>
-        <p:txBody>
-          <a:bodyPr rtlCol="0" anchor="ctr" wrap="square" lIns="45720" rIns="45720" tIns="27432" bIns="27432"/>
-          <a:lstStyle/>
-          <a:p>
-            <a:pPr algn="ctr"/>
-            <a:r>
-              <a:rPr sz="1200" b="0" i="0">
-                <a:solidFill>
-                  <a:srgbClr val="222222"/>
-                </a:solidFill>
-                <a:latin typeface="Calibri"/>
-              </a:rPr>
-              <a:t>Hamilton apportionment (engineering)</a:t>
-            </a:r>
-          </a:p>
-        </p:txBody>
-      </p:sp>
-      <p:sp>
-        <p:nvSpPr>
-          <p:cNvPr id="25" name="Rectangle 24"/>
-          <p:cNvSpPr/>
-          <p:nvPr/>
-        </p:nvSpPr>
-        <p:spPr>
-          <a:xfrm>
-            <a:off x="640080" y="4800600"/>
-            <a:ext cx="5120640" cy="502920"/>
-          </a:xfrm>
-          <a:prstGeom prst="rect">
-            <a:avLst/>
-          </a:prstGeom>
-          <a:solidFill>
-            <a:srgbClr val="F0F0F2"/>
-          </a:solidFill>
-          <a:ln w="15875">
-            <a:solidFill>
-              <a:srgbClr val="636363"/>
-            </a:solidFill>
-          </a:ln>
-          <a:effectLst/>
-        </p:spPr>
-        <p:style>
-          <a:lnRef idx="1">
-            <a:schemeClr val="accent1"/>
-          </a:lnRef>
-          <a:fillRef idx="3">
-            <a:schemeClr val="accent1"/>
-          </a:fillRef>
-          <a:effectRef idx="2">
-            <a:schemeClr val="accent1"/>
-          </a:effectRef>
-          <a:fontRef idx="minor">
-            <a:schemeClr val="lt1"/>
-          </a:fontRef>
-        </p:style>
-        <p:txBody>
-          <a:bodyPr rtlCol="0" anchor="ctr" wrap="square" lIns="45720" rIns="45720" tIns="27432" bIns="27432"/>
-          <a:lstStyle/>
-          <a:p>
-            <a:pPr algn="ctr"/>
-            <a:r>
-              <a:rPr sz="1200" b="0" i="0">
-                <a:solidFill>
-                  <a:srgbClr val="222222"/>
-                </a:solidFill>
-                <a:latin typeface="Calibri"/>
-              </a:rPr>
-              <a:t>Greedy baseline, token Jaccard</a:t>
-            </a:r>
-          </a:p>
-        </p:txBody>
-      </p:sp>
-      <p:sp>
-        <p:nvSpPr>
-          <p:cNvPr id="26" name="Rectangle 25"/>
-          <p:cNvSpPr/>
-          <p:nvPr/>
-        </p:nvSpPr>
-        <p:spPr>
-          <a:xfrm>
-            <a:off x="5852160" y="4800600"/>
-            <a:ext cx="5760720" cy="502920"/>
-          </a:xfrm>
-          <a:prstGeom prst="rect">
-            <a:avLst/>
-          </a:prstGeom>
-          <a:solidFill>
-            <a:srgbClr val="F0F0F2"/>
-          </a:solidFill>
-          <a:ln w="15875">
-            <a:solidFill>
-              <a:srgbClr val="636363"/>
-            </a:solidFill>
-          </a:ln>
-          <a:effectLst/>
-        </p:spPr>
-        <p:style>
-          <a:lnRef idx="1">
-            <a:schemeClr val="accent1"/>
-          </a:lnRef>
-          <a:fillRef idx="3">
-            <a:schemeClr val="accent1"/>
-          </a:fillRef>
-          <a:effectRef idx="2">
-            <a:schemeClr val="accent1"/>
-          </a:effectRef>
-          <a:fontRef idx="minor">
-            <a:schemeClr val="lt1"/>
-          </a:fontRef>
-        </p:style>
-        <p:txBody>
-          <a:bodyPr rtlCol="0" anchor="ctr" wrap="square" lIns="45720" rIns="45720" tIns="27432" bIns="27432"/>
-          <a:lstStyle/>
-          <a:p>
-            <a:pPr algn="ctr"/>
-            <a:r>
-              <a:rPr sz="1200" b="0" i="0">
-                <a:solidFill>
-                  <a:srgbClr val="222222"/>
-                </a:solidFill>
-                <a:latin typeface="Calibri"/>
-              </a:rPr>
-              <a:t>project-specific engineering</a:t>
-            </a:r>
-          </a:p>
-        </p:txBody>
-      </p:sp>
-      <p:sp>
-        <p:nvSpPr>
-          <p:cNvPr id="27" name="TextBox 26"/>
+                <a:latin typeface="Consolas"/>
+              </a:rPr>
+              <a:t>python -m quizgen --pool questions.json --blueprint blueprint.yaml \</a:t>
+            </a:r>
+          </a:p>
+          <a:p>
+            <a:pPr algn="ctr"/>
+            <a:r>
+              <a:rPr sz="1400" b="0" i="0">
+                <a:solidFill>
+                  <a:srgbClr val="FFFFFF"/>
+                </a:solidFill>
+                <a:latin typeface="Consolas"/>
+              </a:rPr>
+              <a:t>    --dedup --validate --out-dir out</a:t>
+            </a:r>
+          </a:p>
+        </p:txBody>
+      </p:sp>
+      <p:sp>
+        <p:nvSpPr>
+          <p:cNvPr id="15" name="TextBox 14"/>
           <p:cNvSpPr txBox="1"/>
           <p:nvPr/>
         </p:nvSpPr>
         <p:spPr>
           <a:xfrm>
-            <a:off x="640080" y="6126480"/>
-            <a:ext cx="11338560" cy="365760"/>
+            <a:off x="640080" y="4846320"/>
+            <a:ext cx="10972800" cy="1645920"/>
           </a:xfrm>
           <a:prstGeom prst="rect">
             <a:avLst/>
@@ -4788,20 +4149,56 @@
           <a:noFill/>
         </p:spPr>
         <p:txBody>
-          <a:bodyPr wrap="square" anchor="t">
+          <a:bodyPr wrap="square">
             <a:spAutoFit/>
           </a:bodyPr>
           <a:lstStyle/>
           <a:p>
-            <a:pPr algn="l"/>
-            <a:r>
-              <a:rPr sz="1100" b="0" i="1">
-                <a:solidFill>
-                  <a:srgbClr val="636363"/>
-                </a:solidFill>
-                <a:latin typeface="Calibri"/>
-              </a:rPr>
-              <a:t>See docs/references.bib for the full, verified bibliography.</a:t>
+            <a:pPr>
+              <a:spcAft>
+                <a:spcPts val="700"/>
+              </a:spcAft>
+            </a:pPr>
+            <a:r>
+              <a:rPr sz="1500">
+                <a:solidFill>
+                  <a:srgbClr val="222222"/>
+                </a:solidFill>
+                <a:latin typeface="Calibri"/>
+              </a:rPr>
+              <a:t>• Writes one Quiz JSON per version (each embeds the resolved blueprint).</a:t>
+            </a:r>
+          </a:p>
+          <a:p>
+            <a:pPr>
+              <a:spcAft>
+                <a:spcPts val="700"/>
+              </a:spcAft>
+            </a:pPr>
+            <a:r>
+              <a:rPr sz="1500">
+                <a:solidFill>
+                  <a:srgbClr val="222222"/>
+                </a:solidFill>
+                <a:latin typeface="Calibri"/>
+              </a:rPr>
+              <a:t>• Standalone entry points too: python -m quizgen.assemble, python -m quizgen.validate.</a:t>
+            </a:r>
+          </a:p>
+          <a:p>
+            <a:pPr>
+              <a:spcAft>
+                <a:spcPts val="700"/>
+              </a:spcAft>
+            </a:pPr>
+            <a:r>
+              <a:rPr sz="1500">
+                <a:solidFill>
+                  <a:srgbClr val="222222"/>
+                </a:solidFill>
+                <a:latin typeface="Calibri"/>
+              </a:rPr>
+              <a:t>• Exits non-zero on any non-compliant version → composes in scripts &amp; CI.</a:t>
             </a:r>
           </a:p>
         </p:txBody>
@@ -4833,6 +4230,1281 @@
         <p:spPr>
           <a:xfrm>
             <a:off x="0" y="0"/>
+            <a:ext cx="12191695" cy="914400"/>
+          </a:xfrm>
+          <a:prstGeom prst="rect">
+            <a:avLst/>
+          </a:prstGeom>
+          <a:solidFill>
+            <a:srgbClr val="002F5E"/>
+          </a:solidFill>
+          <a:ln>
+            <a:noFill/>
+          </a:ln>
+          <a:effectLst/>
+        </p:spPr>
+        <p:style>
+          <a:lnRef idx="1">
+            <a:schemeClr val="accent1"/>
+          </a:lnRef>
+          <a:fillRef idx="3">
+            <a:schemeClr val="accent1"/>
+          </a:fillRef>
+          <a:effectRef idx="2">
+            <a:schemeClr val="accent1"/>
+          </a:effectRef>
+          <a:fontRef idx="minor">
+            <a:schemeClr val="lt1"/>
+          </a:fontRef>
+        </p:style>
+        <p:txBody>
+          <a:bodyPr rtlCol="0" anchor="ctr"/>
+          <a:lstStyle/>
+          <a:p>
+            <a:pPr algn="ctr"/>
+          </a:p>
+        </p:txBody>
+      </p:sp>
+      <p:sp>
+        <p:nvSpPr>
+          <p:cNvPr id="3" name="Rectangle 2"/>
+          <p:cNvSpPr/>
+          <p:nvPr/>
+        </p:nvSpPr>
+        <p:spPr>
+          <a:xfrm>
+            <a:off x="0" y="914400"/>
+            <a:ext cx="12191695" cy="54864"/>
+          </a:xfrm>
+          <a:prstGeom prst="rect">
+            <a:avLst/>
+          </a:prstGeom>
+          <a:solidFill>
+            <a:srgbClr val="00B1EB"/>
+          </a:solidFill>
+          <a:ln>
+            <a:noFill/>
+          </a:ln>
+          <a:effectLst/>
+        </p:spPr>
+        <p:style>
+          <a:lnRef idx="1">
+            <a:schemeClr val="accent1"/>
+          </a:lnRef>
+          <a:fillRef idx="3">
+            <a:schemeClr val="accent1"/>
+          </a:fillRef>
+          <a:effectRef idx="2">
+            <a:schemeClr val="accent1"/>
+          </a:effectRef>
+          <a:fontRef idx="minor">
+            <a:schemeClr val="lt1"/>
+          </a:fontRef>
+        </p:style>
+        <p:txBody>
+          <a:bodyPr rtlCol="0" anchor="ctr"/>
+          <a:lstStyle/>
+          <a:p>
+            <a:pPr algn="ctr"/>
+          </a:p>
+        </p:txBody>
+      </p:sp>
+      <p:sp>
+        <p:nvSpPr>
+          <p:cNvPr id="4" name="TextBox 3"/>
+          <p:cNvSpPr txBox="1"/>
+          <p:nvPr/>
+        </p:nvSpPr>
+        <p:spPr>
+          <a:xfrm>
+            <a:off x="457200" y="109728"/>
+            <a:ext cx="10058400" cy="713232"/>
+          </a:xfrm>
+          <a:prstGeom prst="rect">
+            <a:avLst/>
+          </a:prstGeom>
+          <a:noFill/>
+        </p:spPr>
+        <p:txBody>
+          <a:bodyPr wrap="square" anchor="ctr">
+            <a:spAutoFit/>
+          </a:bodyPr>
+          <a:lstStyle/>
+          <a:p>
+            <a:pPr algn="l"/>
+            <a:r>
+              <a:rPr sz="2800" b="1" i="0">
+                <a:solidFill>
+                  <a:srgbClr val="FFFFFF"/>
+                </a:solidFill>
+                <a:latin typeface="Calibri"/>
+              </a:rPr>
+              <a:t>Where each technique comes from</a:t>
+            </a:r>
+          </a:p>
+        </p:txBody>
+      </p:sp>
+      <p:sp>
+        <p:nvSpPr>
+          <p:cNvPr id="5" name="TextBox 4"/>
+          <p:cNvSpPr txBox="1"/>
+          <p:nvPr/>
+        </p:nvSpPr>
+        <p:spPr>
+          <a:xfrm>
+            <a:off x="10881360" y="164592"/>
+            <a:ext cx="1188720" cy="640080"/>
+          </a:xfrm>
+          <a:prstGeom prst="rect">
+            <a:avLst/>
+          </a:prstGeom>
+          <a:noFill/>
+        </p:spPr>
+        <p:txBody>
+          <a:bodyPr wrap="square" anchor="ctr">
+            <a:spAutoFit/>
+          </a:bodyPr>
+          <a:lstStyle/>
+          <a:p>
+            <a:pPr algn="r"/>
+            <a:r>
+              <a:rPr sz="2600" b="1" i="0">
+                <a:solidFill>
+                  <a:srgbClr val="00B1EB"/>
+                </a:solidFill>
+                <a:latin typeface="Calibri"/>
+              </a:rPr>
+              <a:t>FAU</a:t>
+            </a:r>
+          </a:p>
+        </p:txBody>
+      </p:sp>
+      <p:sp>
+        <p:nvSpPr>
+          <p:cNvPr id="6" name="TextBox 5"/>
+          <p:cNvSpPr txBox="1"/>
+          <p:nvPr/>
+        </p:nvSpPr>
+        <p:spPr>
+          <a:xfrm>
+            <a:off x="475488" y="-18288"/>
+            <a:ext cx="9144000" cy="256032"/>
+          </a:xfrm>
+          <a:prstGeom prst="rect">
+            <a:avLst/>
+          </a:prstGeom>
+          <a:noFill/>
+        </p:spPr>
+        <p:txBody>
+          <a:bodyPr wrap="square" anchor="t">
+            <a:spAutoFit/>
+          </a:bodyPr>
+          <a:lstStyle/>
+          <a:p>
+            <a:pPr algn="l"/>
+            <a:r>
+              <a:rPr sz="1100" b="1" i="0">
+                <a:solidFill>
+                  <a:srgbClr val="00B1EB"/>
+                </a:solidFill>
+                <a:latin typeface="Calibri"/>
+              </a:rPr>
+              <a:t>TECHNIQUE → SOURCE LINEAGE</a:t>
+            </a:r>
+          </a:p>
+        </p:txBody>
+      </p:sp>
+      <p:sp>
+        <p:nvSpPr>
+          <p:cNvPr id="7" name="Rectangle 6"/>
+          <p:cNvSpPr/>
+          <p:nvPr/>
+        </p:nvSpPr>
+        <p:spPr>
+          <a:xfrm>
+            <a:off x="0" y="6565392"/>
+            <a:ext cx="12191695" cy="18288"/>
+          </a:xfrm>
+          <a:prstGeom prst="rect">
+            <a:avLst/>
+          </a:prstGeom>
+          <a:solidFill>
+            <a:srgbClr val="00B1EB"/>
+          </a:solidFill>
+          <a:ln>
+            <a:noFill/>
+          </a:ln>
+          <a:effectLst/>
+        </p:spPr>
+        <p:style>
+          <a:lnRef idx="1">
+            <a:schemeClr val="accent1"/>
+          </a:lnRef>
+          <a:fillRef idx="3">
+            <a:schemeClr val="accent1"/>
+          </a:fillRef>
+          <a:effectRef idx="2">
+            <a:schemeClr val="accent1"/>
+          </a:effectRef>
+          <a:fontRef idx="minor">
+            <a:schemeClr val="lt1"/>
+          </a:fontRef>
+        </p:style>
+        <p:txBody>
+          <a:bodyPr rtlCol="0" anchor="ctr"/>
+          <a:lstStyle/>
+          <a:p>
+            <a:pPr algn="ctr"/>
+          </a:p>
+        </p:txBody>
+      </p:sp>
+      <p:sp>
+        <p:nvSpPr>
+          <p:cNvPr id="8" name="TextBox 7"/>
+          <p:cNvSpPr txBox="1"/>
+          <p:nvPr/>
+        </p:nvSpPr>
+        <p:spPr>
+          <a:xfrm>
+            <a:off x="457200" y="6583680"/>
+            <a:ext cx="2743200" cy="256032"/>
+          </a:xfrm>
+          <a:prstGeom prst="rect">
+            <a:avLst/>
+          </a:prstGeom>
+          <a:noFill/>
+        </p:spPr>
+        <p:txBody>
+          <a:bodyPr wrap="square" anchor="t">
+            <a:spAutoFit/>
+          </a:bodyPr>
+          <a:lstStyle/>
+          <a:p>
+            <a:pPr algn="l"/>
+            <a:r>
+              <a:rPr sz="900" b="0" i="0">
+                <a:solidFill>
+                  <a:srgbClr val="002F5E"/>
+                </a:solidFill>
+                <a:latin typeface="Calibri"/>
+              </a:rPr>
+              <a:t>J. Hayashi</a:t>
+            </a:r>
+          </a:p>
+        </p:txBody>
+      </p:sp>
+      <p:sp>
+        <p:nvSpPr>
+          <p:cNvPr id="9" name="TextBox 8"/>
+          <p:cNvSpPr txBox="1"/>
+          <p:nvPr/>
+        </p:nvSpPr>
+        <p:spPr>
+          <a:xfrm>
+            <a:off x="3200400" y="6583680"/>
+            <a:ext cx="5760720" cy="256032"/>
+          </a:xfrm>
+          <a:prstGeom prst="rect">
+            <a:avLst/>
+          </a:prstGeom>
+          <a:noFill/>
+        </p:spPr>
+        <p:txBody>
+          <a:bodyPr wrap="square" anchor="t">
+            <a:spAutoFit/>
+          </a:bodyPr>
+          <a:lstStyle/>
+          <a:p>
+            <a:pPr algn="ctr"/>
+            <a:r>
+              <a:rPr sz="900" b="0" i="0">
+                <a:solidFill>
+                  <a:srgbClr val="636363"/>
+                </a:solidFill>
+                <a:latin typeface="Calibri"/>
+              </a:rPr>
+              <a:t>quizgen — Automated Test Assembly</a:t>
+            </a:r>
+          </a:p>
+        </p:txBody>
+      </p:sp>
+      <p:sp>
+        <p:nvSpPr>
+          <p:cNvPr id="10" name="TextBox 9"/>
+          <p:cNvSpPr txBox="1"/>
+          <p:nvPr/>
+        </p:nvSpPr>
+        <p:spPr>
+          <a:xfrm>
+            <a:off x="8778240" y="6583680"/>
+            <a:ext cx="2926080" cy="256032"/>
+          </a:xfrm>
+          <a:prstGeom prst="rect">
+            <a:avLst/>
+          </a:prstGeom>
+          <a:noFill/>
+        </p:spPr>
+        <p:txBody>
+          <a:bodyPr wrap="square" anchor="t">
+            <a:spAutoFit/>
+          </a:bodyPr>
+          <a:lstStyle/>
+          <a:p>
+            <a:pPr algn="r"/>
+            <a:r>
+              <a:rPr sz="900" b="0" i="0">
+                <a:solidFill>
+                  <a:srgbClr val="002F5E"/>
+                </a:solidFill>
+                <a:latin typeface="Calibri"/>
+              </a:rPr>
+              <a:t>FAU Erlangen-Nürnberg   10</a:t>
+            </a:r>
+          </a:p>
+        </p:txBody>
+      </p:sp>
+      <p:sp>
+        <p:nvSpPr>
+          <p:cNvPr id="11" name="Rounded Rectangle 10"/>
+          <p:cNvSpPr/>
+          <p:nvPr/>
+        </p:nvSpPr>
+        <p:spPr>
+          <a:xfrm>
+            <a:off x="640080" y="1280160"/>
+            <a:ext cx="5120640" cy="502920"/>
+          </a:xfrm>
+          <a:prstGeom prst="roundRect">
+            <a:avLst/>
+          </a:prstGeom>
+          <a:solidFill>
+            <a:srgbClr val="002F5E"/>
+          </a:solidFill>
+          <a:ln w="15875">
+            <a:solidFill>
+              <a:srgbClr val="002F5E"/>
+            </a:solidFill>
+          </a:ln>
+          <a:effectLst/>
+        </p:spPr>
+        <p:style>
+          <a:lnRef idx="1">
+            <a:schemeClr val="accent1"/>
+          </a:lnRef>
+          <a:fillRef idx="3">
+            <a:schemeClr val="accent1"/>
+          </a:fillRef>
+          <a:effectRef idx="2">
+            <a:schemeClr val="accent1"/>
+          </a:effectRef>
+          <a:fontRef idx="minor">
+            <a:schemeClr val="lt1"/>
+          </a:fontRef>
+        </p:style>
+        <p:txBody>
+          <a:bodyPr rtlCol="0" anchor="ctr" wrap="square" lIns="45720" rIns="45720" tIns="27432" bIns="27432"/>
+          <a:lstStyle/>
+          <a:p>
+            <a:pPr algn="ctr"/>
+            <a:r>
+              <a:rPr sz="1400" b="1" i="0">
+                <a:solidFill>
+                  <a:srgbClr val="FFFFFF"/>
+                </a:solidFill>
+                <a:latin typeface="Calibri"/>
+              </a:rPr>
+              <a:t>Implemented in code</a:t>
+            </a:r>
+          </a:p>
+        </p:txBody>
+      </p:sp>
+      <p:sp>
+        <p:nvSpPr>
+          <p:cNvPr id="12" name="Rounded Rectangle 11"/>
+          <p:cNvSpPr/>
+          <p:nvPr/>
+        </p:nvSpPr>
+        <p:spPr>
+          <a:xfrm>
+            <a:off x="5852160" y="1280160"/>
+            <a:ext cx="5760720" cy="502920"/>
+          </a:xfrm>
+          <a:prstGeom prst="roundRect">
+            <a:avLst/>
+          </a:prstGeom>
+          <a:solidFill>
+            <a:srgbClr val="002F5E"/>
+          </a:solidFill>
+          <a:ln w="15875">
+            <a:solidFill>
+              <a:srgbClr val="002F5E"/>
+            </a:solidFill>
+          </a:ln>
+          <a:effectLst/>
+        </p:spPr>
+        <p:style>
+          <a:lnRef idx="1">
+            <a:schemeClr val="accent1"/>
+          </a:lnRef>
+          <a:fillRef idx="3">
+            <a:schemeClr val="accent1"/>
+          </a:fillRef>
+          <a:effectRef idx="2">
+            <a:schemeClr val="accent1"/>
+          </a:effectRef>
+          <a:fontRef idx="minor">
+            <a:schemeClr val="lt1"/>
+          </a:fontRef>
+        </p:style>
+        <p:txBody>
+          <a:bodyPr rtlCol="0" anchor="ctr" wrap="square" lIns="45720" rIns="45720" tIns="27432" bIns="27432"/>
+          <a:lstStyle/>
+          <a:p>
+            <a:pPr algn="ctr"/>
+            <a:r>
+              <a:rPr sz="1400" b="1" i="0">
+                <a:solidFill>
+                  <a:srgbClr val="FFFFFF"/>
+                </a:solidFill>
+                <a:latin typeface="Calibri"/>
+              </a:rPr>
+              <a:t>Source lineage</a:t>
+            </a:r>
+          </a:p>
+        </p:txBody>
+      </p:sp>
+      <p:sp>
+        <p:nvSpPr>
+          <p:cNvPr id="13" name="Rectangle 12"/>
+          <p:cNvSpPr/>
+          <p:nvPr/>
+        </p:nvSpPr>
+        <p:spPr>
+          <a:xfrm>
+            <a:off x="640080" y="1783080"/>
+            <a:ext cx="5120640" cy="502920"/>
+          </a:xfrm>
+          <a:prstGeom prst="rect">
+            <a:avLst/>
+          </a:prstGeom>
+          <a:solidFill>
+            <a:srgbClr val="F0F0F2"/>
+          </a:solidFill>
+          <a:ln w="15875">
+            <a:solidFill>
+              <a:srgbClr val="636363"/>
+            </a:solidFill>
+          </a:ln>
+          <a:effectLst/>
+        </p:spPr>
+        <p:style>
+          <a:lnRef idx="1">
+            <a:schemeClr val="accent1"/>
+          </a:lnRef>
+          <a:fillRef idx="3">
+            <a:schemeClr val="accent1"/>
+          </a:fillRef>
+          <a:effectRef idx="2">
+            <a:schemeClr val="accent1"/>
+          </a:effectRef>
+          <a:fontRef idx="minor">
+            <a:schemeClr val="lt1"/>
+          </a:fontRef>
+        </p:style>
+        <p:txBody>
+          <a:bodyPr rtlCol="0" anchor="ctr" wrap="square" lIns="45720" rIns="45720" tIns="27432" bIns="27432"/>
+          <a:lstStyle/>
+          <a:p>
+            <a:pPr algn="ctr"/>
+            <a:r>
+              <a:rPr sz="1200" b="0" i="0">
+                <a:solidFill>
+                  <a:srgbClr val="222222"/>
+                </a:solidFill>
+                <a:latin typeface="Calibri"/>
+              </a:rPr>
+              <a:t>Test assembly as 0–1 MIP</a:t>
+            </a:r>
+          </a:p>
+        </p:txBody>
+      </p:sp>
+      <p:sp>
+        <p:nvSpPr>
+          <p:cNvPr id="14" name="Rectangle 13"/>
+          <p:cNvSpPr/>
+          <p:nvPr/>
+        </p:nvSpPr>
+        <p:spPr>
+          <a:xfrm>
+            <a:off x="5852160" y="1783080"/>
+            <a:ext cx="5760720" cy="502920"/>
+          </a:xfrm>
+          <a:prstGeom prst="rect">
+            <a:avLst/>
+          </a:prstGeom>
+          <a:solidFill>
+            <a:srgbClr val="F0F0F2"/>
+          </a:solidFill>
+          <a:ln w="15875">
+            <a:solidFill>
+              <a:srgbClr val="636363"/>
+            </a:solidFill>
+          </a:ln>
+          <a:effectLst/>
+        </p:spPr>
+        <p:style>
+          <a:lnRef idx="1">
+            <a:schemeClr val="accent1"/>
+          </a:lnRef>
+          <a:fillRef idx="3">
+            <a:schemeClr val="accent1"/>
+          </a:fillRef>
+          <a:effectRef idx="2">
+            <a:schemeClr val="accent1"/>
+          </a:effectRef>
+          <a:fontRef idx="minor">
+            <a:schemeClr val="lt1"/>
+          </a:fontRef>
+        </p:style>
+        <p:txBody>
+          <a:bodyPr rtlCol="0" anchor="ctr" wrap="square" lIns="45720" rIns="45720" tIns="27432" bIns="27432"/>
+          <a:lstStyle/>
+          <a:p>
+            <a:pPr algn="ctr"/>
+            <a:r>
+              <a:rPr sz="1200" b="0" i="0">
+                <a:solidFill>
+                  <a:srgbClr val="222222"/>
+                </a:solidFill>
+                <a:latin typeface="Calibri"/>
+              </a:rPr>
+              <a:t>van der Linden 2005 — optimal test design</a:t>
+            </a:r>
+          </a:p>
+        </p:txBody>
+      </p:sp>
+      <p:sp>
+        <p:nvSpPr>
+          <p:cNvPr id="15" name="Rectangle 14"/>
+          <p:cNvSpPr/>
+          <p:nvPr/>
+        </p:nvSpPr>
+        <p:spPr>
+          <a:xfrm>
+            <a:off x="640080" y="2286000"/>
+            <a:ext cx="5120640" cy="502920"/>
+          </a:xfrm>
+          <a:prstGeom prst="rect">
+            <a:avLst/>
+          </a:prstGeom>
+          <a:solidFill>
+            <a:srgbClr val="FFFFFF"/>
+          </a:solidFill>
+          <a:ln w="15875">
+            <a:solidFill>
+              <a:srgbClr val="636363"/>
+            </a:solidFill>
+          </a:ln>
+          <a:effectLst/>
+        </p:spPr>
+        <p:style>
+          <a:lnRef idx="1">
+            <a:schemeClr val="accent1"/>
+          </a:lnRef>
+          <a:fillRef idx="3">
+            <a:schemeClr val="accent1"/>
+          </a:fillRef>
+          <a:effectRef idx="2">
+            <a:schemeClr val="accent1"/>
+          </a:effectRef>
+          <a:fontRef idx="minor">
+            <a:schemeClr val="lt1"/>
+          </a:fontRef>
+        </p:style>
+        <p:txBody>
+          <a:bodyPr rtlCol="0" anchor="ctr" wrap="square" lIns="45720" rIns="45720" tIns="27432" bIns="27432"/>
+          <a:lstStyle/>
+          <a:p>
+            <a:pPr algn="ctr"/>
+            <a:r>
+              <a:rPr sz="1200" b="0" i="0">
+                <a:solidFill>
+                  <a:srgbClr val="222222"/>
+                </a:solidFill>
+                <a:latin typeface="Calibri"/>
+              </a:rPr>
+              <a:t>Quality-weighted selection</a:t>
+            </a:r>
+          </a:p>
+        </p:txBody>
+      </p:sp>
+      <p:sp>
+        <p:nvSpPr>
+          <p:cNvPr id="16" name="Rectangle 15"/>
+          <p:cNvSpPr/>
+          <p:nvPr/>
+        </p:nvSpPr>
+        <p:spPr>
+          <a:xfrm>
+            <a:off x="5852160" y="2286000"/>
+            <a:ext cx="5760720" cy="502920"/>
+          </a:xfrm>
+          <a:prstGeom prst="rect">
+            <a:avLst/>
+          </a:prstGeom>
+          <a:solidFill>
+            <a:srgbClr val="FFFFFF"/>
+          </a:solidFill>
+          <a:ln w="15875">
+            <a:solidFill>
+              <a:srgbClr val="636363"/>
+            </a:solidFill>
+          </a:ln>
+          <a:effectLst/>
+        </p:spPr>
+        <p:style>
+          <a:lnRef idx="1">
+            <a:schemeClr val="accent1"/>
+          </a:lnRef>
+          <a:fillRef idx="3">
+            <a:schemeClr val="accent1"/>
+          </a:fillRef>
+          <a:effectRef idx="2">
+            <a:schemeClr val="accent1"/>
+          </a:effectRef>
+          <a:fontRef idx="minor">
+            <a:schemeClr val="lt1"/>
+          </a:fontRef>
+        </p:style>
+        <p:txBody>
+          <a:bodyPr rtlCol="0" anchor="ctr" wrap="square" lIns="45720" rIns="45720" tIns="27432" bIns="27432"/>
+          <a:lstStyle/>
+          <a:p>
+            <a:pPr algn="ctr"/>
+            <a:r>
+              <a:rPr sz="1200" b="0" i="0">
+                <a:solidFill>
+                  <a:srgbClr val="222222"/>
+                </a:solidFill>
+                <a:latin typeface="Calibri"/>
+              </a:rPr>
+              <a:t>van der Linden 2005 (objective in ATA)</a:t>
+            </a:r>
+          </a:p>
+        </p:txBody>
+      </p:sp>
+      <p:sp>
+        <p:nvSpPr>
+          <p:cNvPr id="17" name="Rectangle 16"/>
+          <p:cNvSpPr/>
+          <p:nvPr/>
+        </p:nvSpPr>
+        <p:spPr>
+          <a:xfrm>
+            <a:off x="640080" y="2788920"/>
+            <a:ext cx="5120640" cy="502920"/>
+          </a:xfrm>
+          <a:prstGeom prst="rect">
+            <a:avLst/>
+          </a:prstGeom>
+          <a:solidFill>
+            <a:srgbClr val="F0F0F2"/>
+          </a:solidFill>
+          <a:ln w="15875">
+            <a:solidFill>
+              <a:srgbClr val="636363"/>
+            </a:solidFill>
+          </a:ln>
+          <a:effectLst/>
+        </p:spPr>
+        <p:style>
+          <a:lnRef idx="1">
+            <a:schemeClr val="accent1"/>
+          </a:lnRef>
+          <a:fillRef idx="3">
+            <a:schemeClr val="accent1"/>
+          </a:fillRef>
+          <a:effectRef idx="2">
+            <a:schemeClr val="accent1"/>
+          </a:effectRef>
+          <a:fontRef idx="minor">
+            <a:schemeClr val="lt1"/>
+          </a:fontRef>
+        </p:style>
+        <p:txBody>
+          <a:bodyPr rtlCol="0" anchor="ctr" wrap="square" lIns="45720" rIns="45720" tIns="27432" bIns="27432"/>
+          <a:lstStyle/>
+          <a:p>
+            <a:pPr algn="ctr"/>
+            <a:r>
+              <a:rPr sz="1200" b="0" i="0">
+                <a:solidFill>
+                  <a:srgbClr val="222222"/>
+                </a:solidFill>
+                <a:latin typeface="Calibri"/>
+              </a:rPr>
+              <a:t>Test blueprint / type &amp; difficulty mix</a:t>
+            </a:r>
+          </a:p>
+        </p:txBody>
+      </p:sp>
+      <p:sp>
+        <p:nvSpPr>
+          <p:cNvPr id="18" name="Rectangle 17"/>
+          <p:cNvSpPr/>
+          <p:nvPr/>
+        </p:nvSpPr>
+        <p:spPr>
+          <a:xfrm>
+            <a:off x="5852160" y="2788920"/>
+            <a:ext cx="5760720" cy="502920"/>
+          </a:xfrm>
+          <a:prstGeom prst="rect">
+            <a:avLst/>
+          </a:prstGeom>
+          <a:solidFill>
+            <a:srgbClr val="F0F0F2"/>
+          </a:solidFill>
+          <a:ln w="15875">
+            <a:solidFill>
+              <a:srgbClr val="636363"/>
+            </a:solidFill>
+          </a:ln>
+          <a:effectLst/>
+        </p:spPr>
+        <p:style>
+          <a:lnRef idx="1">
+            <a:schemeClr val="accent1"/>
+          </a:lnRef>
+          <a:fillRef idx="3">
+            <a:schemeClr val="accent1"/>
+          </a:fillRef>
+          <a:effectRef idx="2">
+            <a:schemeClr val="accent1"/>
+          </a:effectRef>
+          <a:fontRef idx="minor">
+            <a:schemeClr val="lt1"/>
+          </a:fontRef>
+        </p:style>
+        <p:txBody>
+          <a:bodyPr rtlCol="0" anchor="ctr" wrap="square" lIns="45720" rIns="45720" tIns="27432" bIns="27432"/>
+          <a:lstStyle/>
+          <a:p>
+            <a:pPr algn="ctr"/>
+            <a:r>
+              <a:rPr sz="1200" b="0" i="0">
+                <a:solidFill>
+                  <a:srgbClr val="222222"/>
+                </a:solidFill>
+                <a:latin typeface="Calibri"/>
+              </a:rPr>
+              <a:t>classical table-of-specifications design</a:t>
+            </a:r>
+          </a:p>
+        </p:txBody>
+      </p:sp>
+      <p:sp>
+        <p:nvSpPr>
+          <p:cNvPr id="19" name="Rectangle 18"/>
+          <p:cNvSpPr/>
+          <p:nvPr/>
+        </p:nvSpPr>
+        <p:spPr>
+          <a:xfrm>
+            <a:off x="640080" y="3291840"/>
+            <a:ext cx="5120640" cy="502920"/>
+          </a:xfrm>
+          <a:prstGeom prst="rect">
+            <a:avLst/>
+          </a:prstGeom>
+          <a:solidFill>
+            <a:srgbClr val="FFFFFF"/>
+          </a:solidFill>
+          <a:ln w="15875">
+            <a:solidFill>
+              <a:srgbClr val="636363"/>
+            </a:solidFill>
+          </a:ln>
+          <a:effectLst/>
+        </p:spPr>
+        <p:style>
+          <a:lnRef idx="1">
+            <a:schemeClr val="accent1"/>
+          </a:lnRef>
+          <a:fillRef idx="3">
+            <a:schemeClr val="accent1"/>
+          </a:fillRef>
+          <a:effectRef idx="2">
+            <a:schemeClr val="accent1"/>
+          </a:effectRef>
+          <a:fontRef idx="minor">
+            <a:schemeClr val="lt1"/>
+          </a:fontRef>
+        </p:style>
+        <p:txBody>
+          <a:bodyPr rtlCol="0" anchor="ctr" wrap="square" lIns="45720" rIns="45720" tIns="27432" bIns="27432"/>
+          <a:lstStyle/>
+          <a:p>
+            <a:pPr algn="ctr"/>
+            <a:r>
+              <a:rPr sz="1200" b="0" i="0">
+                <a:solidFill>
+                  <a:srgbClr val="222222"/>
+                </a:solidFill>
+                <a:latin typeface="Calibri"/>
+              </a:rPr>
+              <a:t>Bloom-level metadata</a:t>
+            </a:r>
+          </a:p>
+        </p:txBody>
+      </p:sp>
+      <p:sp>
+        <p:nvSpPr>
+          <p:cNvPr id="20" name="Rectangle 19"/>
+          <p:cNvSpPr/>
+          <p:nvPr/>
+        </p:nvSpPr>
+        <p:spPr>
+          <a:xfrm>
+            <a:off x="5852160" y="3291840"/>
+            <a:ext cx="5760720" cy="502920"/>
+          </a:xfrm>
+          <a:prstGeom prst="rect">
+            <a:avLst/>
+          </a:prstGeom>
+          <a:solidFill>
+            <a:srgbClr val="FFFFFF"/>
+          </a:solidFill>
+          <a:ln w="15875">
+            <a:solidFill>
+              <a:srgbClr val="636363"/>
+            </a:solidFill>
+          </a:ln>
+          <a:effectLst/>
+        </p:spPr>
+        <p:style>
+          <a:lnRef idx="1">
+            <a:schemeClr val="accent1"/>
+          </a:lnRef>
+          <a:fillRef idx="3">
+            <a:schemeClr val="accent1"/>
+          </a:fillRef>
+          <a:effectRef idx="2">
+            <a:schemeClr val="accent1"/>
+          </a:effectRef>
+          <a:fontRef idx="minor">
+            <a:schemeClr val="lt1"/>
+          </a:fontRef>
+        </p:style>
+        <p:txBody>
+          <a:bodyPr rtlCol="0" anchor="ctr" wrap="square" lIns="45720" rIns="45720" tIns="27432" bIns="27432"/>
+          <a:lstStyle/>
+          <a:p>
+            <a:pPr algn="ctr"/>
+            <a:r>
+              <a:rPr sz="1200" b="0" i="0">
+                <a:solidFill>
+                  <a:srgbClr val="222222"/>
+                </a:solidFill>
+                <a:latin typeface="Calibri"/>
+              </a:rPr>
+              <a:t>Anderson &amp; Krathwohl 2001 (revised Bloom)</a:t>
+            </a:r>
+          </a:p>
+        </p:txBody>
+      </p:sp>
+      <p:sp>
+        <p:nvSpPr>
+          <p:cNvPr id="21" name="Rectangle 20"/>
+          <p:cNvSpPr/>
+          <p:nvPr/>
+        </p:nvSpPr>
+        <p:spPr>
+          <a:xfrm>
+            <a:off x="640080" y="3794760"/>
+            <a:ext cx="5120640" cy="502920"/>
+          </a:xfrm>
+          <a:prstGeom prst="rect">
+            <a:avLst/>
+          </a:prstGeom>
+          <a:solidFill>
+            <a:srgbClr val="F0F0F2"/>
+          </a:solidFill>
+          <a:ln w="15875">
+            <a:solidFill>
+              <a:srgbClr val="636363"/>
+            </a:solidFill>
+          </a:ln>
+          <a:effectLst/>
+        </p:spPr>
+        <p:style>
+          <a:lnRef idx="1">
+            <a:schemeClr val="accent1"/>
+          </a:lnRef>
+          <a:fillRef idx="3">
+            <a:schemeClr val="accent1"/>
+          </a:fillRef>
+          <a:effectRef idx="2">
+            <a:schemeClr val="accent1"/>
+          </a:effectRef>
+          <a:fontRef idx="minor">
+            <a:schemeClr val="lt1"/>
+          </a:fontRef>
+        </p:style>
+        <p:txBody>
+          <a:bodyPr rtlCol="0" anchor="ctr" wrap="square" lIns="45720" rIns="45720" tIns="27432" bIns="27432"/>
+          <a:lstStyle/>
+          <a:p>
+            <a:pPr algn="ctr"/>
+            <a:r>
+              <a:rPr sz="1200" b="0" i="0">
+                <a:solidFill>
+                  <a:srgbClr val="222222"/>
+                </a:solidFill>
+                <a:latin typeface="Calibri"/>
+              </a:rPr>
+              <a:t>Semantic dedup (embeddings)</a:t>
+            </a:r>
+          </a:p>
+        </p:txBody>
+      </p:sp>
+      <p:sp>
+        <p:nvSpPr>
+          <p:cNvPr id="22" name="Rectangle 21"/>
+          <p:cNvSpPr/>
+          <p:nvPr/>
+        </p:nvSpPr>
+        <p:spPr>
+          <a:xfrm>
+            <a:off x="5852160" y="3794760"/>
+            <a:ext cx="5760720" cy="502920"/>
+          </a:xfrm>
+          <a:prstGeom prst="rect">
+            <a:avLst/>
+          </a:prstGeom>
+          <a:solidFill>
+            <a:srgbClr val="F0F0F2"/>
+          </a:solidFill>
+          <a:ln w="15875">
+            <a:solidFill>
+              <a:srgbClr val="636363"/>
+            </a:solidFill>
+          </a:ln>
+          <a:effectLst/>
+        </p:spPr>
+        <p:style>
+          <a:lnRef idx="1">
+            <a:schemeClr val="accent1"/>
+          </a:lnRef>
+          <a:fillRef idx="3">
+            <a:schemeClr val="accent1"/>
+          </a:fillRef>
+          <a:effectRef idx="2">
+            <a:schemeClr val="accent1"/>
+          </a:effectRef>
+          <a:fontRef idx="minor">
+            <a:schemeClr val="lt1"/>
+          </a:fontRef>
+        </p:style>
+        <p:txBody>
+          <a:bodyPr rtlCol="0" anchor="ctr" wrap="square" lIns="45720" rIns="45720" tIns="27432" bIns="27432"/>
+          <a:lstStyle/>
+          <a:p>
+            <a:pPr algn="ctr"/>
+            <a:r>
+              <a:rPr sz="1200" b="0" i="0">
+                <a:solidFill>
+                  <a:srgbClr val="222222"/>
+                </a:solidFill>
+                <a:latin typeface="Calibri"/>
+              </a:rPr>
+              <a:t>Sentence-BERT (Reimers &amp; Gurevych 2019)</a:t>
+            </a:r>
+          </a:p>
+        </p:txBody>
+      </p:sp>
+      <p:sp>
+        <p:nvSpPr>
+          <p:cNvPr id="23" name="Rectangle 22"/>
+          <p:cNvSpPr/>
+          <p:nvPr/>
+        </p:nvSpPr>
+        <p:spPr>
+          <a:xfrm>
+            <a:off x="640080" y="4297680"/>
+            <a:ext cx="5120640" cy="502920"/>
+          </a:xfrm>
+          <a:prstGeom prst="rect">
+            <a:avLst/>
+          </a:prstGeom>
+          <a:solidFill>
+            <a:srgbClr val="FFFFFF"/>
+          </a:solidFill>
+          <a:ln w="15875">
+            <a:solidFill>
+              <a:srgbClr val="636363"/>
+            </a:solidFill>
+          </a:ln>
+          <a:effectLst/>
+        </p:spPr>
+        <p:style>
+          <a:lnRef idx="1">
+            <a:schemeClr val="accent1"/>
+          </a:lnRef>
+          <a:fillRef idx="3">
+            <a:schemeClr val="accent1"/>
+          </a:fillRef>
+          <a:effectRef idx="2">
+            <a:schemeClr val="accent1"/>
+          </a:effectRef>
+          <a:fontRef idx="minor">
+            <a:schemeClr val="lt1"/>
+          </a:fontRef>
+        </p:style>
+        <p:txBody>
+          <a:bodyPr rtlCol="0" anchor="ctr" wrap="square" lIns="45720" rIns="45720" tIns="27432" bIns="27432"/>
+          <a:lstStyle/>
+          <a:p>
+            <a:pPr algn="ctr"/>
+            <a:r>
+              <a:rPr sz="1200" b="0" i="0">
+                <a:solidFill>
+                  <a:srgbClr val="222222"/>
+                </a:solidFill>
+                <a:latin typeface="Calibri"/>
+              </a:rPr>
+              <a:t>Largest-remainder counts</a:t>
+            </a:r>
+          </a:p>
+        </p:txBody>
+      </p:sp>
+      <p:sp>
+        <p:nvSpPr>
+          <p:cNvPr id="24" name="Rectangle 23"/>
+          <p:cNvSpPr/>
+          <p:nvPr/>
+        </p:nvSpPr>
+        <p:spPr>
+          <a:xfrm>
+            <a:off x="5852160" y="4297680"/>
+            <a:ext cx="5760720" cy="502920"/>
+          </a:xfrm>
+          <a:prstGeom prst="rect">
+            <a:avLst/>
+          </a:prstGeom>
+          <a:solidFill>
+            <a:srgbClr val="FFFFFF"/>
+          </a:solidFill>
+          <a:ln w="15875">
+            <a:solidFill>
+              <a:srgbClr val="636363"/>
+            </a:solidFill>
+          </a:ln>
+          <a:effectLst/>
+        </p:spPr>
+        <p:style>
+          <a:lnRef idx="1">
+            <a:schemeClr val="accent1"/>
+          </a:lnRef>
+          <a:fillRef idx="3">
+            <a:schemeClr val="accent1"/>
+          </a:fillRef>
+          <a:effectRef idx="2">
+            <a:schemeClr val="accent1"/>
+          </a:effectRef>
+          <a:fontRef idx="minor">
+            <a:schemeClr val="lt1"/>
+          </a:fontRef>
+        </p:style>
+        <p:txBody>
+          <a:bodyPr rtlCol="0" anchor="ctr" wrap="square" lIns="45720" rIns="45720" tIns="27432" bIns="27432"/>
+          <a:lstStyle/>
+          <a:p>
+            <a:pPr algn="ctr"/>
+            <a:r>
+              <a:rPr sz="1200" b="0" i="0">
+                <a:solidFill>
+                  <a:srgbClr val="222222"/>
+                </a:solidFill>
+                <a:latin typeface="Calibri"/>
+              </a:rPr>
+              <a:t>Hamilton apportionment (engineering)</a:t>
+            </a:r>
+          </a:p>
+        </p:txBody>
+      </p:sp>
+      <p:sp>
+        <p:nvSpPr>
+          <p:cNvPr id="25" name="Rectangle 24"/>
+          <p:cNvSpPr/>
+          <p:nvPr/>
+        </p:nvSpPr>
+        <p:spPr>
+          <a:xfrm>
+            <a:off x="640080" y="4800600"/>
+            <a:ext cx="5120640" cy="502920"/>
+          </a:xfrm>
+          <a:prstGeom prst="rect">
+            <a:avLst/>
+          </a:prstGeom>
+          <a:solidFill>
+            <a:srgbClr val="F0F0F2"/>
+          </a:solidFill>
+          <a:ln w="15875">
+            <a:solidFill>
+              <a:srgbClr val="636363"/>
+            </a:solidFill>
+          </a:ln>
+          <a:effectLst/>
+        </p:spPr>
+        <p:style>
+          <a:lnRef idx="1">
+            <a:schemeClr val="accent1"/>
+          </a:lnRef>
+          <a:fillRef idx="3">
+            <a:schemeClr val="accent1"/>
+          </a:fillRef>
+          <a:effectRef idx="2">
+            <a:schemeClr val="accent1"/>
+          </a:effectRef>
+          <a:fontRef idx="minor">
+            <a:schemeClr val="lt1"/>
+          </a:fontRef>
+        </p:style>
+        <p:txBody>
+          <a:bodyPr rtlCol="0" anchor="ctr" wrap="square" lIns="45720" rIns="45720" tIns="27432" bIns="27432"/>
+          <a:lstStyle/>
+          <a:p>
+            <a:pPr algn="ctr"/>
+            <a:r>
+              <a:rPr sz="1200" b="0" i="0">
+                <a:solidFill>
+                  <a:srgbClr val="222222"/>
+                </a:solidFill>
+                <a:latin typeface="Calibri"/>
+              </a:rPr>
+              <a:t>Greedy baseline, token Jaccard</a:t>
+            </a:r>
+          </a:p>
+        </p:txBody>
+      </p:sp>
+      <p:sp>
+        <p:nvSpPr>
+          <p:cNvPr id="26" name="Rectangle 25"/>
+          <p:cNvSpPr/>
+          <p:nvPr/>
+        </p:nvSpPr>
+        <p:spPr>
+          <a:xfrm>
+            <a:off x="5852160" y="4800600"/>
+            <a:ext cx="5760720" cy="502920"/>
+          </a:xfrm>
+          <a:prstGeom prst="rect">
+            <a:avLst/>
+          </a:prstGeom>
+          <a:solidFill>
+            <a:srgbClr val="F0F0F2"/>
+          </a:solidFill>
+          <a:ln w="15875">
+            <a:solidFill>
+              <a:srgbClr val="636363"/>
+            </a:solidFill>
+          </a:ln>
+          <a:effectLst/>
+        </p:spPr>
+        <p:style>
+          <a:lnRef idx="1">
+            <a:schemeClr val="accent1"/>
+          </a:lnRef>
+          <a:fillRef idx="3">
+            <a:schemeClr val="accent1"/>
+          </a:fillRef>
+          <a:effectRef idx="2">
+            <a:schemeClr val="accent1"/>
+          </a:effectRef>
+          <a:fontRef idx="minor">
+            <a:schemeClr val="lt1"/>
+          </a:fontRef>
+        </p:style>
+        <p:txBody>
+          <a:bodyPr rtlCol="0" anchor="ctr" wrap="square" lIns="45720" rIns="45720" tIns="27432" bIns="27432"/>
+          <a:lstStyle/>
+          <a:p>
+            <a:pPr algn="ctr"/>
+            <a:r>
+              <a:rPr sz="1200" b="0" i="0">
+                <a:solidFill>
+                  <a:srgbClr val="222222"/>
+                </a:solidFill>
+                <a:latin typeface="Calibri"/>
+              </a:rPr>
+              <a:t>project-specific engineering</a:t>
+            </a:r>
+          </a:p>
+        </p:txBody>
+      </p:sp>
+      <p:sp>
+        <p:nvSpPr>
+          <p:cNvPr id="27" name="TextBox 26"/>
+          <p:cNvSpPr txBox="1"/>
+          <p:nvPr/>
+        </p:nvSpPr>
+        <p:spPr>
+          <a:xfrm>
+            <a:off x="640080" y="6126480"/>
+            <a:ext cx="11338560" cy="365760"/>
+          </a:xfrm>
+          <a:prstGeom prst="rect">
+            <a:avLst/>
+          </a:prstGeom>
+          <a:noFill/>
+        </p:spPr>
+        <p:txBody>
+          <a:bodyPr wrap="square" anchor="t">
+            <a:spAutoFit/>
+          </a:bodyPr>
+          <a:lstStyle/>
+          <a:p>
+            <a:pPr algn="l"/>
+            <a:r>
+              <a:rPr sz="1100" b="0" i="1">
+                <a:solidFill>
+                  <a:srgbClr val="636363"/>
+                </a:solidFill>
+                <a:latin typeface="Calibri"/>
+              </a:rPr>
+              <a:t>See docs/references.bib for the full, verified bibliography.</a:t>
+            </a:r>
+          </a:p>
+        </p:txBody>
+      </p:sp>
+    </p:spTree>
+  </p:cSld>
+  <p:clrMapOvr>
+    <a:masterClrMapping/>
+  </p:clrMapOvr>
+</p:sld>
+</file>
+
+<file path=ppt/slides/slide12.xml><?xml version="1.0" encoding="utf-8"?>
+<p:sld xmlns:a="http://schemas.openxmlformats.org/drawingml/2006/main" xmlns:p="http://schemas.openxmlformats.org/presentationml/2006/main" xmlns:r="http://schemas.openxmlformats.org/officeDocument/2006/relationships">
+  <p:cSld>
+    <p:spTree>
+      <p:nvGrpSpPr>
+        <p:cNvPr id="1" name=""/>
+        <p:cNvGrpSpPr/>
+        <p:nvPr/>
+      </p:nvGrpSpPr>
+      <p:grpSpPr/>
+      <p:sp>
+        <p:nvSpPr>
+          <p:cNvPr id="2" name="Rectangle 1"/>
+          <p:cNvSpPr/>
+          <p:nvPr/>
+        </p:nvSpPr>
+        <p:spPr>
+          <a:xfrm>
+            <a:off x="0" y="0"/>
             <a:ext cx="12191695" cy="6858000"/>
           </a:xfrm>
           <a:prstGeom prst="rect">
@@ -9341,7 +10013,7 @@
                 </a:solidFill>
                 <a:latin typeface="Calibri"/>
               </a:rPr>
-              <a:t>Balanced formats, not all multiple-choice</a:t>
+              <a:t>What the equations actually say</a:t>
             </a:r>
           </a:p>
         </p:txBody>
@@ -9411,7 +10083,7 @@
                 </a:solidFill>
                 <a:latin typeface="Calibri"/>
               </a:rPr>
-              <a:t>WHY qtype_mix MATTERS</a:t>
+              <a:t>THE MIP IN PLAIN WORDS</a:t>
             </a:r>
           </a:p>
         </p:txBody>
@@ -9573,8 +10245,8 @@
         </p:nvSpPr>
         <p:spPr>
           <a:xfrm>
-            <a:off x="640080" y="1188720"/>
-            <a:ext cx="10972800" cy="731520"/>
+            <a:off x="640080" y="1097280"/>
+            <a:ext cx="11155680" cy="548640"/>
           </a:xfrm>
           <a:prstGeom prst="rect">
             <a:avLst/>
@@ -9589,13 +10261,13 @@
           <a:p>
             <a:pPr algn="l"/>
             <a:r>
-              <a:rPr sz="1700" b="0" i="0">
-                <a:solidFill>
-                  <a:srgbClr val="222222"/>
-                </a:solidFill>
-                <a:latin typeface="Calibri"/>
-              </a:rPr>
-              <a:t>The quality objective rewards well-formed MCQs (+0.2). With no constraint on the type distribution, the optimiser fills every free slot with MCQs.</a:t>
+              <a:rPr sz="1500" b="0" i="1">
+                <a:solidFill>
+                  <a:srgbClr val="636363"/>
+                </a:solidFill>
+                <a:latin typeface="Calibri"/>
+              </a:rPr>
+              <a:t>A MIP is just: lots of yes/no choices  +  one goal  +  rules to obey. The solver flips the switches to score as high as it can while breaking no rule.</a:t>
             </a:r>
           </a:p>
         </p:txBody>
@@ -9608,18 +10280,18 @@
         </p:nvSpPr>
         <p:spPr>
           <a:xfrm>
-            <a:off x="640080" y="2286000"/>
-            <a:ext cx="5212080" cy="548640"/>
+            <a:off x="640080" y="1737360"/>
+            <a:ext cx="4114800" cy="530352"/>
           </a:xfrm>
           <a:prstGeom prst="roundRect">
             <a:avLst/>
           </a:prstGeom>
           <a:solidFill>
-            <a:srgbClr val="DE2D26"/>
+            <a:srgbClr val="002F5E"/>
           </a:solidFill>
           <a:ln w="15875">
             <a:solidFill>
-              <a:srgbClr val="DE2D26"/>
+              <a:srgbClr val="002F5E"/>
             </a:solidFill>
           </a:ln>
           <a:effectLst/>
@@ -9644,37 +10316,37 @@
           <a:p>
             <a:pPr algn="ctr"/>
             <a:r>
-              <a:rPr sz="1500" b="1" i="0">
+              <a:rPr sz="1300" b="1" i="0">
                 <a:solidFill>
                   <a:srgbClr val="FFFFFF"/>
                 </a:solidFill>
                 <a:latin typeface="Calibri"/>
               </a:rPr>
-              <a:t>Without qtype_mix</a:t>
-            </a:r>
-          </a:p>
-        </p:txBody>
-      </p:sp>
-      <p:sp>
-        <p:nvSpPr>
-          <p:cNvPr id="13" name="Rectangle 12"/>
+              <a:t>The maths</a:t>
+            </a:r>
+          </a:p>
+        </p:txBody>
+      </p:sp>
+      <p:sp>
+        <p:nvSpPr>
+          <p:cNvPr id="13" name="Rounded Rectangle 12"/>
           <p:cNvSpPr/>
           <p:nvPr/>
         </p:nvSpPr>
         <p:spPr>
           <a:xfrm>
-            <a:off x="640080" y="2926080"/>
-            <a:ext cx="5212080" cy="1463040"/>
-          </a:xfrm>
-          <a:prstGeom prst="rect">
+            <a:off x="4846320" y="1737360"/>
+            <a:ext cx="6766560" cy="530352"/>
+          </a:xfrm>
+          <a:prstGeom prst="roundRect">
             <a:avLst/>
           </a:prstGeom>
           <a:solidFill>
-            <a:srgbClr val="FDE0DD"/>
+            <a:srgbClr val="002F5E"/>
           </a:solidFill>
           <a:ln w="15875">
             <a:solidFill>
-              <a:srgbClr val="DE2D26"/>
+              <a:srgbClr val="002F5E"/>
             </a:solidFill>
           </a:ln>
           <a:effectLst/>
@@ -9699,64 +10371,37 @@
           <a:p>
             <a:pPr algn="ctr"/>
             <a:r>
-              <a:rPr sz="1500" b="0" i="0">
-                <a:solidFill>
-                  <a:srgbClr val="222222"/>
-                </a:solidFill>
-                <a:latin typeface="Calibri"/>
-              </a:rPr>
-              <a:t>v1: mcq 18 · short_answer 1 · cloze 1</a:t>
-            </a:r>
-          </a:p>
-          <a:p>
-            <a:pPr algn="ctr"/>
-            <a:r>
-              <a:rPr sz="1500" b="0" i="0">
-                <a:solidFill>
-                  <a:srgbClr val="222222"/>
-                </a:solidFill>
-                <a:latin typeface="Calibri"/>
-              </a:rPr>
-              <a:t>v2: mcq 19 · short_answer 1</a:t>
-            </a:r>
-          </a:p>
-          <a:p>
-            <a:pPr algn="ctr"/>
-          </a:p>
-          <a:p>
-            <a:pPr algn="ctr"/>
-            <a:r>
-              <a:rPr sz="1500" b="0" i="0">
-                <a:solidFill>
-                  <a:srgbClr val="222222"/>
-                </a:solidFill>
-                <a:latin typeface="Calibri"/>
-              </a:rPr>
-              <a:t>→ effectively all MCQ</a:t>
-            </a:r>
-          </a:p>
-        </p:txBody>
-      </p:sp>
-      <p:sp>
-        <p:nvSpPr>
-          <p:cNvPr id="14" name="Rounded Rectangle 13"/>
+              <a:rPr sz="1300" b="1" i="0">
+                <a:solidFill>
+                  <a:srgbClr val="FFFFFF"/>
+                </a:solidFill>
+                <a:latin typeface="Calibri"/>
+              </a:rPr>
+              <a:t>What it says, in everyday words</a:t>
+            </a:r>
+          </a:p>
+        </p:txBody>
+      </p:sp>
+      <p:sp>
+        <p:nvSpPr>
+          <p:cNvPr id="14" name="Rectangle 13"/>
           <p:cNvSpPr/>
           <p:nvPr/>
         </p:nvSpPr>
         <p:spPr>
           <a:xfrm>
-            <a:off x="6400800" y="2286000"/>
-            <a:ext cx="5212080" cy="548640"/>
-          </a:xfrm>
-          <a:prstGeom prst="roundRect">
+            <a:off x="640080" y="2267712"/>
+            <a:ext cx="4114800" cy="530352"/>
+          </a:xfrm>
+          <a:prstGeom prst="rect">
             <a:avLst/>
           </a:prstGeom>
           <a:solidFill>
-            <a:srgbClr val="31A354"/>
+            <a:srgbClr val="F0F0F2"/>
           </a:solidFill>
           <a:ln w="15875">
             <a:solidFill>
-              <a:srgbClr val="31A354"/>
+              <a:srgbClr val="636363"/>
             </a:solidFill>
           </a:ln>
           <a:effectLst/>
@@ -9781,13 +10426,13 @@
           <a:p>
             <a:pPr algn="ctr"/>
             <a:r>
-              <a:rPr sz="1500" b="1" i="0">
-                <a:solidFill>
-                  <a:srgbClr val="FFFFFF"/>
-                </a:solidFill>
-                <a:latin typeface="Calibri"/>
-              </a:rPr>
-              <a:t>With qtype_mix (0.4/0.2/0.2/0.2)</a:t>
+              <a:rPr sz="1200" b="0" i="0">
+                <a:solidFill>
+                  <a:srgbClr val="222222"/>
+                </a:solidFill>
+                <a:latin typeface="Consolas"/>
+              </a:rPr>
+              <a:t>x(i,v) = 1 or 0</a:t>
             </a:r>
           </a:p>
         </p:txBody>
@@ -9800,18 +10445,18 @@
         </p:nvSpPr>
         <p:spPr>
           <a:xfrm>
-            <a:off x="6400800" y="2926080"/>
-            <a:ext cx="5212080" cy="1463040"/>
+            <a:off x="4846320" y="2267712"/>
+            <a:ext cx="6766560" cy="530352"/>
           </a:xfrm>
           <a:prstGeom prst="rect">
             <a:avLst/>
           </a:prstGeom>
           <a:solidFill>
-            <a:srgbClr val="E5F5E0"/>
+            <a:srgbClr val="F0F0F2"/>
           </a:solidFill>
           <a:ln w="15875">
             <a:solidFill>
-              <a:srgbClr val="31A354"/>
+              <a:srgbClr val="636363"/>
             </a:solidFill>
           </a:ln>
           <a:effectLst/>
@@ -9836,54 +10481,687 @@
           <a:p>
             <a:pPr algn="ctr"/>
             <a:r>
-              <a:rPr sz="1500" b="0" i="0">
+              <a:rPr sz="1200" b="0" i="0">
                 <a:solidFill>
                   <a:srgbClr val="222222"/>
                 </a:solidFill>
                 <a:latin typeface="Calibri"/>
               </a:rPr>
-              <a:t>v1: mcq 8 · true_false 4 · short_answer 4 · cloze 4</a:t>
-            </a:r>
-          </a:p>
-          <a:p>
-            <a:pPr algn="ctr"/>
-            <a:r>
-              <a:rPr sz="1500" b="0" i="0">
+              <a:t>An on/off switch for each question on each paper.  ON = use it here;  OFF = leave it out.</a:t>
+            </a:r>
+          </a:p>
+        </p:txBody>
+      </p:sp>
+      <p:sp>
+        <p:nvSpPr>
+          <p:cNvPr id="16" name="Rectangle 15"/>
+          <p:cNvSpPr/>
+          <p:nvPr/>
+        </p:nvSpPr>
+        <p:spPr>
+          <a:xfrm>
+            <a:off x="640080" y="2798064"/>
+            <a:ext cx="4114800" cy="530352"/>
+          </a:xfrm>
+          <a:prstGeom prst="rect">
+            <a:avLst/>
+          </a:prstGeom>
+          <a:solidFill>
+            <a:srgbClr val="FFFFFF"/>
+          </a:solidFill>
+          <a:ln w="15875">
+            <a:solidFill>
+              <a:srgbClr val="636363"/>
+            </a:solidFill>
+          </a:ln>
+          <a:effectLst/>
+        </p:spPr>
+        <p:style>
+          <a:lnRef idx="1">
+            <a:schemeClr val="accent1"/>
+          </a:lnRef>
+          <a:fillRef idx="3">
+            <a:schemeClr val="accent1"/>
+          </a:fillRef>
+          <a:effectRef idx="2">
+            <a:schemeClr val="accent1"/>
+          </a:effectRef>
+          <a:fontRef idx="minor">
+            <a:schemeClr val="lt1"/>
+          </a:fontRef>
+        </p:style>
+        <p:txBody>
+          <a:bodyPr rtlCol="0" anchor="ctr" wrap="square" lIns="45720" rIns="45720" tIns="27432" bIns="27432"/>
+          <a:lstStyle/>
+          <a:p>
+            <a:pPr algn="ctr"/>
+            <a:r>
+              <a:rPr sz="1200" b="0" i="0">
                 <a:solidFill>
                   <a:srgbClr val="222222"/>
                 </a:solidFill>
-                <a:latin typeface="Calibri"/>
-              </a:rPr>
-              <a:t>v2: mcq 8 · true_false 4 · short_answer 4 · cloze 4</a:t>
-            </a:r>
-          </a:p>
-          <a:p>
-            <a:pPr algn="ctr"/>
-          </a:p>
-          <a:p>
-            <a:pPr algn="ctr"/>
-            <a:r>
-              <a:rPr sz="1500" b="0" i="0">
+                <a:latin typeface="Consolas"/>
+              </a:rPr>
+              <a:t>maximise  Σ q(i)·x(i,v)</a:t>
+            </a:r>
+          </a:p>
+        </p:txBody>
+      </p:sp>
+      <p:sp>
+        <p:nvSpPr>
+          <p:cNvPr id="17" name="Rectangle 16"/>
+          <p:cNvSpPr/>
+          <p:nvPr/>
+        </p:nvSpPr>
+        <p:spPr>
+          <a:xfrm>
+            <a:off x="4846320" y="2798064"/>
+            <a:ext cx="6766560" cy="530352"/>
+          </a:xfrm>
+          <a:prstGeom prst="rect">
+            <a:avLst/>
+          </a:prstGeom>
+          <a:solidFill>
+            <a:srgbClr val="FFFFFF"/>
+          </a:solidFill>
+          <a:ln w="15875">
+            <a:solidFill>
+              <a:srgbClr val="636363"/>
+            </a:solidFill>
+          </a:ln>
+          <a:effectLst/>
+        </p:spPr>
+        <p:style>
+          <a:lnRef idx="1">
+            <a:schemeClr val="accent1"/>
+          </a:lnRef>
+          <a:fillRef idx="3">
+            <a:schemeClr val="accent1"/>
+          </a:fillRef>
+          <a:effectRef idx="2">
+            <a:schemeClr val="accent1"/>
+          </a:effectRef>
+          <a:fontRef idx="minor">
+            <a:schemeClr val="lt1"/>
+          </a:fontRef>
+        </p:style>
+        <p:txBody>
+          <a:bodyPr rtlCol="0" anchor="ctr" wrap="square" lIns="45720" rIns="45720" tIns="27432" bIns="27432"/>
+          <a:lstStyle/>
+          <a:p>
+            <a:pPr algn="ctr"/>
+            <a:r>
+              <a:rPr sz="1200" b="0" i="0">
                 <a:solidFill>
                   <a:srgbClr val="222222"/>
                 </a:solidFill>
                 <a:latin typeface="Calibri"/>
               </a:rPr>
-              <a:t>→ exact, balanced, still optimal</a:t>
-            </a:r>
-          </a:p>
-        </p:txBody>
-      </p:sp>
-      <p:sp>
-        <p:nvSpPr>
-          <p:cNvPr id="16" name="TextBox 15"/>
+              <a:t>Every question has a quality score. Turn ON the switches that add up to the best total.</a:t>
+            </a:r>
+          </a:p>
+        </p:txBody>
+      </p:sp>
+      <p:sp>
+        <p:nvSpPr>
+          <p:cNvPr id="18" name="Rectangle 17"/>
+          <p:cNvSpPr/>
+          <p:nvPr/>
+        </p:nvSpPr>
+        <p:spPr>
+          <a:xfrm>
+            <a:off x="640080" y="3328416"/>
+            <a:ext cx="4114800" cy="530352"/>
+          </a:xfrm>
+          <a:prstGeom prst="rect">
+            <a:avLst/>
+          </a:prstGeom>
+          <a:solidFill>
+            <a:srgbClr val="F0F0F2"/>
+          </a:solidFill>
+          <a:ln w="15875">
+            <a:solidFill>
+              <a:srgbClr val="636363"/>
+            </a:solidFill>
+          </a:ln>
+          <a:effectLst/>
+        </p:spPr>
+        <p:style>
+          <a:lnRef idx="1">
+            <a:schemeClr val="accent1"/>
+          </a:lnRef>
+          <a:fillRef idx="3">
+            <a:schemeClr val="accent1"/>
+          </a:fillRef>
+          <a:effectRef idx="2">
+            <a:schemeClr val="accent1"/>
+          </a:effectRef>
+          <a:fontRef idx="minor">
+            <a:schemeClr val="lt1"/>
+          </a:fontRef>
+        </p:style>
+        <p:txBody>
+          <a:bodyPr rtlCol="0" anchor="ctr" wrap="square" lIns="45720" rIns="45720" tIns="27432" bIns="27432"/>
+          <a:lstStyle/>
+          <a:p>
+            <a:pPr algn="ctr"/>
+            <a:r>
+              <a:rPr sz="1200" b="0" i="0">
+                <a:solidFill>
+                  <a:srgbClr val="222222"/>
+                </a:solidFill>
+                <a:latin typeface="Consolas"/>
+              </a:rPr>
+              <a:t>Σ x(i,v) = n_c    (chapter)</a:t>
+            </a:r>
+          </a:p>
+        </p:txBody>
+      </p:sp>
+      <p:sp>
+        <p:nvSpPr>
+          <p:cNvPr id="19" name="Rectangle 18"/>
+          <p:cNvSpPr/>
+          <p:nvPr/>
+        </p:nvSpPr>
+        <p:spPr>
+          <a:xfrm>
+            <a:off x="4846320" y="3328416"/>
+            <a:ext cx="6766560" cy="530352"/>
+          </a:xfrm>
+          <a:prstGeom prst="rect">
+            <a:avLst/>
+          </a:prstGeom>
+          <a:solidFill>
+            <a:srgbClr val="F0F0F2"/>
+          </a:solidFill>
+          <a:ln w="15875">
+            <a:solidFill>
+              <a:srgbClr val="636363"/>
+            </a:solidFill>
+          </a:ln>
+          <a:effectLst/>
+        </p:spPr>
+        <p:style>
+          <a:lnRef idx="1">
+            <a:schemeClr val="accent1"/>
+          </a:lnRef>
+          <a:fillRef idx="3">
+            <a:schemeClr val="accent1"/>
+          </a:fillRef>
+          <a:effectRef idx="2">
+            <a:schemeClr val="accent1"/>
+          </a:effectRef>
+          <a:fontRef idx="minor">
+            <a:schemeClr val="lt1"/>
+          </a:fontRef>
+        </p:style>
+        <p:txBody>
+          <a:bodyPr rtlCol="0" anchor="ctr" wrap="square" lIns="45720" rIns="45720" tIns="27432" bIns="27432"/>
+          <a:lstStyle/>
+          <a:p>
+            <a:pPr algn="ctr"/>
+            <a:r>
+              <a:rPr sz="1200" b="0" i="0">
+                <a:solidFill>
+                  <a:srgbClr val="222222"/>
+                </a:solidFill>
+                <a:latin typeface="Calibri"/>
+              </a:rPr>
+              <a:t>Use EXACTLY the wanted number of questions from each chapter — no more, no less.</a:t>
+            </a:r>
+          </a:p>
+        </p:txBody>
+      </p:sp>
+      <p:sp>
+        <p:nvSpPr>
+          <p:cNvPr id="20" name="Rectangle 19"/>
+          <p:cNvSpPr/>
+          <p:nvPr/>
+        </p:nvSpPr>
+        <p:spPr>
+          <a:xfrm>
+            <a:off x="640080" y="3858768"/>
+            <a:ext cx="4114800" cy="530352"/>
+          </a:xfrm>
+          <a:prstGeom prst="rect">
+            <a:avLst/>
+          </a:prstGeom>
+          <a:solidFill>
+            <a:srgbClr val="FFFFFF"/>
+          </a:solidFill>
+          <a:ln w="15875">
+            <a:solidFill>
+              <a:srgbClr val="636363"/>
+            </a:solidFill>
+          </a:ln>
+          <a:effectLst/>
+        </p:spPr>
+        <p:style>
+          <a:lnRef idx="1">
+            <a:schemeClr val="accent1"/>
+          </a:lnRef>
+          <a:fillRef idx="3">
+            <a:schemeClr val="accent1"/>
+          </a:fillRef>
+          <a:effectRef idx="2">
+            <a:schemeClr val="accent1"/>
+          </a:effectRef>
+          <a:fontRef idx="minor">
+            <a:schemeClr val="lt1"/>
+          </a:fontRef>
+        </p:style>
+        <p:txBody>
+          <a:bodyPr rtlCol="0" anchor="ctr" wrap="square" lIns="45720" rIns="45720" tIns="27432" bIns="27432"/>
+          <a:lstStyle/>
+          <a:p>
+            <a:pPr algn="ctr"/>
+            <a:r>
+              <a:rPr sz="1200" b="0" i="0">
+                <a:solidFill>
+                  <a:srgbClr val="222222"/>
+                </a:solidFill>
+                <a:latin typeface="Consolas"/>
+              </a:rPr>
+              <a:t>Σ x(i,v) = m_d    (difficulty)</a:t>
+            </a:r>
+          </a:p>
+        </p:txBody>
+      </p:sp>
+      <p:sp>
+        <p:nvSpPr>
+          <p:cNvPr id="21" name="Rectangle 20"/>
+          <p:cNvSpPr/>
+          <p:nvPr/>
+        </p:nvSpPr>
+        <p:spPr>
+          <a:xfrm>
+            <a:off x="4846320" y="3858768"/>
+            <a:ext cx="6766560" cy="530352"/>
+          </a:xfrm>
+          <a:prstGeom prst="rect">
+            <a:avLst/>
+          </a:prstGeom>
+          <a:solidFill>
+            <a:srgbClr val="FFFFFF"/>
+          </a:solidFill>
+          <a:ln w="15875">
+            <a:solidFill>
+              <a:srgbClr val="636363"/>
+            </a:solidFill>
+          </a:ln>
+          <a:effectLst/>
+        </p:spPr>
+        <p:style>
+          <a:lnRef idx="1">
+            <a:schemeClr val="accent1"/>
+          </a:lnRef>
+          <a:fillRef idx="3">
+            <a:schemeClr val="accent1"/>
+          </a:fillRef>
+          <a:effectRef idx="2">
+            <a:schemeClr val="accent1"/>
+          </a:effectRef>
+          <a:fontRef idx="minor">
+            <a:schemeClr val="lt1"/>
+          </a:fontRef>
+        </p:style>
+        <p:txBody>
+          <a:bodyPr rtlCol="0" anchor="ctr" wrap="square" lIns="45720" rIns="45720" tIns="27432" bIns="27432"/>
+          <a:lstStyle/>
+          <a:p>
+            <a:pPr algn="ctr"/>
+            <a:r>
+              <a:rPr sz="1200" b="0" i="0">
+                <a:solidFill>
+                  <a:srgbClr val="222222"/>
+                </a:solidFill>
+                <a:latin typeface="Calibri"/>
+              </a:rPr>
+              <a:t>Use EXACTLY the wanted number of easy / medium / hard questions.</a:t>
+            </a:r>
+          </a:p>
+        </p:txBody>
+      </p:sp>
+      <p:sp>
+        <p:nvSpPr>
+          <p:cNvPr id="22" name="Rectangle 21"/>
+          <p:cNvSpPr/>
+          <p:nvPr/>
+        </p:nvSpPr>
+        <p:spPr>
+          <a:xfrm>
+            <a:off x="640080" y="4389120"/>
+            <a:ext cx="4114800" cy="530352"/>
+          </a:xfrm>
+          <a:prstGeom prst="rect">
+            <a:avLst/>
+          </a:prstGeom>
+          <a:solidFill>
+            <a:srgbClr val="F0F0F2"/>
+          </a:solidFill>
+          <a:ln w="15875">
+            <a:solidFill>
+              <a:srgbClr val="636363"/>
+            </a:solidFill>
+          </a:ln>
+          <a:effectLst/>
+        </p:spPr>
+        <p:style>
+          <a:lnRef idx="1">
+            <a:schemeClr val="accent1"/>
+          </a:lnRef>
+          <a:fillRef idx="3">
+            <a:schemeClr val="accent1"/>
+          </a:fillRef>
+          <a:effectRef idx="2">
+            <a:schemeClr val="accent1"/>
+          </a:effectRef>
+          <a:fontRef idx="minor">
+            <a:schemeClr val="lt1"/>
+          </a:fontRef>
+        </p:style>
+        <p:txBody>
+          <a:bodyPr rtlCol="0" anchor="ctr" wrap="square" lIns="45720" rIns="45720" tIns="27432" bIns="27432"/>
+          <a:lstStyle/>
+          <a:p>
+            <a:pPr algn="ctr"/>
+            <a:r>
+              <a:rPr sz="1200" b="0" i="0">
+                <a:solidFill>
+                  <a:srgbClr val="222222"/>
+                </a:solidFill>
+                <a:latin typeface="Consolas"/>
+              </a:rPr>
+              <a:t>Σ x(i,v) = k_p    (type)</a:t>
+            </a:r>
+          </a:p>
+        </p:txBody>
+      </p:sp>
+      <p:sp>
+        <p:nvSpPr>
+          <p:cNvPr id="23" name="Rectangle 22"/>
+          <p:cNvSpPr/>
+          <p:nvPr/>
+        </p:nvSpPr>
+        <p:spPr>
+          <a:xfrm>
+            <a:off x="4846320" y="4389120"/>
+            <a:ext cx="6766560" cy="530352"/>
+          </a:xfrm>
+          <a:prstGeom prst="rect">
+            <a:avLst/>
+          </a:prstGeom>
+          <a:solidFill>
+            <a:srgbClr val="F0F0F2"/>
+          </a:solidFill>
+          <a:ln w="15875">
+            <a:solidFill>
+              <a:srgbClr val="636363"/>
+            </a:solidFill>
+          </a:ln>
+          <a:effectLst/>
+        </p:spPr>
+        <p:style>
+          <a:lnRef idx="1">
+            <a:schemeClr val="accent1"/>
+          </a:lnRef>
+          <a:fillRef idx="3">
+            <a:schemeClr val="accent1"/>
+          </a:fillRef>
+          <a:effectRef idx="2">
+            <a:schemeClr val="accent1"/>
+          </a:effectRef>
+          <a:fontRef idx="minor">
+            <a:schemeClr val="lt1"/>
+          </a:fontRef>
+        </p:style>
+        <p:txBody>
+          <a:bodyPr rtlCol="0" anchor="ctr" wrap="square" lIns="45720" rIns="45720" tIns="27432" bIns="27432"/>
+          <a:lstStyle/>
+          <a:p>
+            <a:pPr algn="ctr"/>
+            <a:r>
+              <a:rPr sz="1200" b="0" i="0">
+                <a:solidFill>
+                  <a:srgbClr val="222222"/>
+                </a:solidFill>
+                <a:latin typeface="Calibri"/>
+              </a:rPr>
+              <a:t>Use EXACTLY the wanted number of each kind (MCQ, true/false, short, cloze).</a:t>
+            </a:r>
+          </a:p>
+        </p:txBody>
+      </p:sp>
+      <p:sp>
+        <p:nvSpPr>
+          <p:cNvPr id="24" name="Rectangle 23"/>
+          <p:cNvSpPr/>
+          <p:nvPr/>
+        </p:nvSpPr>
+        <p:spPr>
+          <a:xfrm>
+            <a:off x="640080" y="4919472"/>
+            <a:ext cx="4114800" cy="530352"/>
+          </a:xfrm>
+          <a:prstGeom prst="rect">
+            <a:avLst/>
+          </a:prstGeom>
+          <a:solidFill>
+            <a:srgbClr val="FFFFFF"/>
+          </a:solidFill>
+          <a:ln w="15875">
+            <a:solidFill>
+              <a:srgbClr val="636363"/>
+            </a:solidFill>
+          </a:ln>
+          <a:effectLst/>
+        </p:spPr>
+        <p:style>
+          <a:lnRef idx="1">
+            <a:schemeClr val="accent1"/>
+          </a:lnRef>
+          <a:fillRef idx="3">
+            <a:schemeClr val="accent1"/>
+          </a:fillRef>
+          <a:effectRef idx="2">
+            <a:schemeClr val="accent1"/>
+          </a:effectRef>
+          <a:fontRef idx="minor">
+            <a:schemeClr val="lt1"/>
+          </a:fontRef>
+        </p:style>
+        <p:txBody>
+          <a:bodyPr rtlCol="0" anchor="ctr" wrap="square" lIns="45720" rIns="45720" tIns="27432" bIns="27432"/>
+          <a:lstStyle/>
+          <a:p>
+            <a:pPr algn="ctr"/>
+            <a:r>
+              <a:rPr sz="1200" b="0" i="0">
+                <a:solidFill>
+                  <a:srgbClr val="222222"/>
+                </a:solidFill>
+                <a:latin typeface="Consolas"/>
+              </a:rPr>
+              <a:t>Σ_v x(i,v) ≤ 1    (no overlap)</a:t>
+            </a:r>
+          </a:p>
+        </p:txBody>
+      </p:sp>
+      <p:sp>
+        <p:nvSpPr>
+          <p:cNvPr id="25" name="Rectangle 24"/>
+          <p:cNvSpPr/>
+          <p:nvPr/>
+        </p:nvSpPr>
+        <p:spPr>
+          <a:xfrm>
+            <a:off x="4846320" y="4919472"/>
+            <a:ext cx="6766560" cy="530352"/>
+          </a:xfrm>
+          <a:prstGeom prst="rect">
+            <a:avLst/>
+          </a:prstGeom>
+          <a:solidFill>
+            <a:srgbClr val="FFFFFF"/>
+          </a:solidFill>
+          <a:ln w="15875">
+            <a:solidFill>
+              <a:srgbClr val="636363"/>
+            </a:solidFill>
+          </a:ln>
+          <a:effectLst/>
+        </p:spPr>
+        <p:style>
+          <a:lnRef idx="1">
+            <a:schemeClr val="accent1"/>
+          </a:lnRef>
+          <a:fillRef idx="3">
+            <a:schemeClr val="accent1"/>
+          </a:fillRef>
+          <a:effectRef idx="2">
+            <a:schemeClr val="accent1"/>
+          </a:effectRef>
+          <a:fontRef idx="minor">
+            <a:schemeClr val="lt1"/>
+          </a:fontRef>
+        </p:style>
+        <p:txBody>
+          <a:bodyPr rtlCol="0" anchor="ctr" wrap="square" lIns="45720" rIns="45720" tIns="27432" bIns="27432"/>
+          <a:lstStyle/>
+          <a:p>
+            <a:pPr algn="ctr"/>
+            <a:r>
+              <a:rPr sz="1200" b="0" i="0">
+                <a:solidFill>
+                  <a:srgbClr val="222222"/>
+                </a:solidFill>
+                <a:latin typeface="Calibri"/>
+              </a:rPr>
+              <a:t>A question may go on at most ONE paper, so two papers never share a question.</a:t>
+            </a:r>
+          </a:p>
+        </p:txBody>
+      </p:sp>
+      <p:sp>
+        <p:nvSpPr>
+          <p:cNvPr id="26" name="Rectangle 25"/>
+          <p:cNvSpPr/>
+          <p:nvPr/>
+        </p:nvSpPr>
+        <p:spPr>
+          <a:xfrm>
+            <a:off x="640080" y="5449824"/>
+            <a:ext cx="4114800" cy="530352"/>
+          </a:xfrm>
+          <a:prstGeom prst="rect">
+            <a:avLst/>
+          </a:prstGeom>
+          <a:solidFill>
+            <a:srgbClr val="F0F0F2"/>
+          </a:solidFill>
+          <a:ln w="15875">
+            <a:solidFill>
+              <a:srgbClr val="636363"/>
+            </a:solidFill>
+          </a:ln>
+          <a:effectLst/>
+        </p:spPr>
+        <p:style>
+          <a:lnRef idx="1">
+            <a:schemeClr val="accent1"/>
+          </a:lnRef>
+          <a:fillRef idx="3">
+            <a:schemeClr val="accent1"/>
+          </a:fillRef>
+          <a:effectRef idx="2">
+            <a:schemeClr val="accent1"/>
+          </a:effectRef>
+          <a:fontRef idx="minor">
+            <a:schemeClr val="lt1"/>
+          </a:fontRef>
+        </p:style>
+        <p:txBody>
+          <a:bodyPr rtlCol="0" anchor="ctr" wrap="square" lIns="45720" rIns="45720" tIns="27432" bIns="27432"/>
+          <a:lstStyle/>
+          <a:p>
+            <a:pPr algn="ctr"/>
+            <a:r>
+              <a:rPr sz="1200" b="0" i="0">
+                <a:solidFill>
+                  <a:srgbClr val="222222"/>
+                </a:solidFill>
+                <a:latin typeface="Consolas"/>
+              </a:rPr>
+              <a:t>x(i,·) + x(j,·) ≤ 1  (near-twins)</a:t>
+            </a:r>
+          </a:p>
+        </p:txBody>
+      </p:sp>
+      <p:sp>
+        <p:nvSpPr>
+          <p:cNvPr id="27" name="Rectangle 26"/>
+          <p:cNvSpPr/>
+          <p:nvPr/>
+        </p:nvSpPr>
+        <p:spPr>
+          <a:xfrm>
+            <a:off x="4846320" y="5449824"/>
+            <a:ext cx="6766560" cy="530352"/>
+          </a:xfrm>
+          <a:prstGeom prst="rect">
+            <a:avLst/>
+          </a:prstGeom>
+          <a:solidFill>
+            <a:srgbClr val="F0F0F2"/>
+          </a:solidFill>
+          <a:ln w="15875">
+            <a:solidFill>
+              <a:srgbClr val="636363"/>
+            </a:solidFill>
+          </a:ln>
+          <a:effectLst/>
+        </p:spPr>
+        <p:style>
+          <a:lnRef idx="1">
+            <a:schemeClr val="accent1"/>
+          </a:lnRef>
+          <a:fillRef idx="3">
+            <a:schemeClr val="accent1"/>
+          </a:fillRef>
+          <a:effectRef idx="2">
+            <a:schemeClr val="accent1"/>
+          </a:effectRef>
+          <a:fontRef idx="minor">
+            <a:schemeClr val="lt1"/>
+          </a:fontRef>
+        </p:style>
+        <p:txBody>
+          <a:bodyPr rtlCol="0" anchor="ctr" wrap="square" lIns="45720" rIns="45720" tIns="27432" bIns="27432"/>
+          <a:lstStyle/>
+          <a:p>
+            <a:pPr algn="ctr"/>
+            <a:r>
+              <a:rPr sz="1200" b="0" i="0">
+                <a:solidFill>
+                  <a:srgbClr val="222222"/>
+                </a:solidFill>
+                <a:latin typeface="Calibri"/>
+              </a:rPr>
+              <a:t>If two questions are almost the same, use at most ONE of them anywhere.</a:t>
+            </a:r>
+          </a:p>
+        </p:txBody>
+      </p:sp>
+      <p:sp>
+        <p:nvSpPr>
+          <p:cNvPr id="28" name="TextBox 27"/>
           <p:cNvSpPr txBox="1"/>
           <p:nvPr/>
         </p:nvSpPr>
         <p:spPr>
           <a:xfrm>
-            <a:off x="640080" y="4846320"/>
-            <a:ext cx="10972800" cy="1280160"/>
+            <a:off x="640080" y="6016752"/>
+            <a:ext cx="11155680" cy="365760"/>
           </a:xfrm>
           <a:prstGeom prst="rect">
             <a:avLst/>
@@ -9898,13 +11176,13 @@
           <a:p>
             <a:pPr algn="l"/>
             <a:r>
-              <a:rPr sz="1600" b="0" i="1">
-                <a:solidFill>
-                  <a:srgbClr val="636363"/>
-                </a:solidFill>
-                <a:latin typeface="Calibri"/>
-              </a:rPr>
-              <a:t>The fix is a constraint, not a hack: qtype_mix is the question-type analogue of difficulty_mix, resolved to exact counts (largest-remainder) and enforced per version by both selectors. Pool stays mixed; the mix becomes guaranteed.</a:t>
+              <a:rPr sz="1200" b="1" i="0">
+                <a:solidFill>
+                  <a:srgbClr val="002F5E"/>
+                </a:solidFill>
+                <a:latin typeface="Calibri"/>
+              </a:rPr>
+              <a:t>The “=” lines are promises kept exactly; the “≤ 1” lines are limits that stop overlap.</a:t>
             </a:r>
           </a:p>
         </p:txBody>
@@ -10045,7 +11323,7 @@
                 </a:solidFill>
                 <a:latin typeface="Calibri"/>
               </a:rPr>
-              <a:t>Deduplication &amp; validation</a:t>
+              <a:t>Balanced formats, not all multiple-choice</a:t>
             </a:r>
           </a:p>
         </p:txBody>
@@ -10115,7 +11393,7 @@
                 </a:solidFill>
                 <a:latin typeface="Calibri"/>
               </a:rPr>
-              <a:t>similarity.py • dedup.py • validate.py</a:t>
+              <a:t>WHY qtype_mix MATTERS</a:t>
             </a:r>
           </a:p>
         </p:txBody>
@@ -10277,8 +11555,8 @@
         </p:nvSpPr>
         <p:spPr>
           <a:xfrm>
-            <a:off x="640080" y="1143000"/>
-            <a:ext cx="5486400" cy="365760"/>
+            <a:off x="640080" y="1188720"/>
+            <a:ext cx="10972800" cy="731520"/>
           </a:xfrm>
           <a:prstGeom prst="rect">
             <a:avLst/>
@@ -10293,108 +11571,37 @@
           <a:p>
             <a:pPr algn="l"/>
             <a:r>
-              <a:rPr sz="1700" b="1" i="0">
-                <a:solidFill>
-                  <a:srgbClr val="002F5E"/>
-                </a:solidFill>
-                <a:latin typeface="Calibri"/>
-              </a:rPr>
-              <a:t>DEDUP (--dedup)</a:t>
-            </a:r>
-          </a:p>
-        </p:txBody>
-      </p:sp>
-      <p:sp>
-        <p:nvSpPr>
-          <p:cNvPr id="12" name="TextBox 11"/>
-          <p:cNvSpPr txBox="1"/>
-          <p:nvPr/>
-        </p:nvSpPr>
-        <p:spPr>
-          <a:xfrm>
-            <a:off x="640080" y="1554480"/>
-            <a:ext cx="5303520" cy="2194560"/>
-          </a:xfrm>
-          <a:prstGeom prst="rect">
-            <a:avLst/>
-          </a:prstGeom>
-          <a:noFill/>
-        </p:spPr>
-        <p:txBody>
-          <a:bodyPr wrap="square">
-            <a:spAutoFit/>
-          </a:bodyPr>
-          <a:lstStyle/>
-          <a:p>
-            <a:pPr>
-              <a:spcAft>
-                <a:spcPts val="700"/>
-              </a:spcAft>
-            </a:pPr>
-            <a:r>
-              <a:rPr sz="1500">
+              <a:rPr sz="1700" b="0" i="0">
                 <a:solidFill>
                   <a:srgbClr val="222222"/>
                 </a:solidFill>
                 <a:latin typeface="Calibri"/>
               </a:rPr>
-              <a:t>• Token-Jaccard over stem+answer(+options) — offline, always on.</a:t>
-            </a:r>
-          </a:p>
-          <a:p>
-            <a:pPr>
-              <a:spcAft>
-                <a:spcPts val="700"/>
-              </a:spcAft>
-            </a:pPr>
-            <a:r>
-              <a:rPr sz="1500">
-                <a:solidFill>
-                  <a:srgbClr val="222222"/>
-                </a:solidFill>
-                <a:latin typeface="Calibri"/>
-              </a:rPr>
-              <a:t>• Optional embedding cosine — catches paraphrases.</a:t>
-            </a:r>
-          </a:p>
-          <a:p>
-            <a:pPr>
-              <a:spcAft>
-                <a:spcPts val="700"/>
-              </a:spcAft>
-            </a:pPr>
-            <a:r>
-              <a:rPr sz="1500">
-                <a:solidFill>
-                  <a:srgbClr val="222222"/>
-                </a:solidFill>
-                <a:latin typeface="Calibri"/>
-              </a:rPr>
-              <a:t>• Drops dups from the pool; MIP also forbids dup pairs across versions.</a:t>
-            </a:r>
-          </a:p>
-        </p:txBody>
-      </p:sp>
-      <p:sp>
-        <p:nvSpPr>
-          <p:cNvPr id="13" name="Rectangle 12"/>
+              <a:t>The quality objective rewards well-formed MCQs (+0.2). With no constraint on the type distribution, the optimiser fills every free slot with MCQs.</a:t>
+            </a:r>
+          </a:p>
+        </p:txBody>
+      </p:sp>
+      <p:sp>
+        <p:nvSpPr>
+          <p:cNvPr id="12" name="Rounded Rectangle 11"/>
           <p:cNvSpPr/>
           <p:nvPr/>
         </p:nvSpPr>
         <p:spPr>
           <a:xfrm>
-            <a:off x="640080" y="3931920"/>
-            <a:ext cx="5212080" cy="1005840"/>
-          </a:xfrm>
-          <a:prstGeom prst="rect">
+            <a:off x="640080" y="2286000"/>
+            <a:ext cx="5212080" cy="548640"/>
+          </a:xfrm>
+          <a:prstGeom prst="roundRect">
             <a:avLst/>
           </a:prstGeom>
           <a:solidFill>
-            <a:srgbClr val="F0F0F2"/>
+            <a:srgbClr val="DE2D26"/>
           </a:solidFill>
           <a:ln w="15875">
             <a:solidFill>
-              <a:srgbClr val="636363"/>
+              <a:srgbClr val="DE2D26"/>
             </a:solidFill>
           </a:ln>
           <a:effectLst/>
@@ -10419,64 +11626,166 @@
           <a:p>
             <a:pPr algn="ctr"/>
             <a:r>
-              <a:rPr sz="1400" b="0" i="0">
+              <a:rPr sz="1500" b="1" i="0">
+                <a:solidFill>
+                  <a:srgbClr val="FFFFFF"/>
+                </a:solidFill>
+                <a:latin typeface="Calibri"/>
+              </a:rPr>
+              <a:t>Without qtype_mix</a:t>
+            </a:r>
+          </a:p>
+        </p:txBody>
+      </p:sp>
+      <p:sp>
+        <p:nvSpPr>
+          <p:cNvPr id="13" name="Rectangle 12"/>
+          <p:cNvSpPr/>
+          <p:nvPr/>
+        </p:nvSpPr>
+        <p:spPr>
+          <a:xfrm>
+            <a:off x="640080" y="2926080"/>
+            <a:ext cx="5212080" cy="1463040"/>
+          </a:xfrm>
+          <a:prstGeom prst="rect">
+            <a:avLst/>
+          </a:prstGeom>
+          <a:solidFill>
+            <a:srgbClr val="FDE0DD"/>
+          </a:solidFill>
+          <a:ln w="15875">
+            <a:solidFill>
+              <a:srgbClr val="DE2D26"/>
+            </a:solidFill>
+          </a:ln>
+          <a:effectLst/>
+        </p:spPr>
+        <p:style>
+          <a:lnRef idx="1">
+            <a:schemeClr val="accent1"/>
+          </a:lnRef>
+          <a:fillRef idx="3">
+            <a:schemeClr val="accent1"/>
+          </a:fillRef>
+          <a:effectRef idx="2">
+            <a:schemeClr val="accent1"/>
+          </a:effectRef>
+          <a:fontRef idx="minor">
+            <a:schemeClr val="lt1"/>
+          </a:fontRef>
+        </p:style>
+        <p:txBody>
+          <a:bodyPr rtlCol="0" anchor="ctr" wrap="square" lIns="45720" rIns="45720" tIns="27432" bIns="27432"/>
+          <a:lstStyle/>
+          <a:p>
+            <a:pPr algn="ctr"/>
+            <a:r>
+              <a:rPr sz="1500" b="0" i="0">
                 <a:solidFill>
                   <a:srgbClr val="222222"/>
                 </a:solidFill>
-                <a:latin typeface="Consolas"/>
-              </a:rPr>
-              <a:t>sim(q₁,q₂) = |T(q₁) ∩ T(q₂)| / |T(q₁) ∪ T(q₂)|</a:t>
-            </a:r>
-          </a:p>
-        </p:txBody>
-      </p:sp>
-      <p:sp>
-        <p:nvSpPr>
-          <p:cNvPr id="14" name="TextBox 13"/>
-          <p:cNvSpPr txBox="1"/>
-          <p:nvPr/>
-        </p:nvSpPr>
-        <p:spPr>
-          <a:xfrm>
-            <a:off x="6400800" y="1143000"/>
-            <a:ext cx="5486400" cy="365760"/>
-          </a:xfrm>
-          <a:prstGeom prst="rect">
-            <a:avLst/>
-          </a:prstGeom>
-          <a:noFill/>
-        </p:spPr>
-        <p:txBody>
-          <a:bodyPr wrap="square" anchor="t">
-            <a:spAutoFit/>
-          </a:bodyPr>
-          <a:lstStyle/>
-          <a:p>
-            <a:pPr algn="l"/>
-            <a:r>
-              <a:rPr sz="1700" b="1" i="0">
-                <a:solidFill>
-                  <a:srgbClr val="31A354"/>
-                </a:solidFill>
-                <a:latin typeface="Calibri"/>
-              </a:rPr>
-              <a:t>VALIDATE (--validate)</a:t>
-            </a:r>
-          </a:p>
-        </p:txBody>
-      </p:sp>
-      <p:sp>
-        <p:nvSpPr>
-          <p:cNvPr id="15" name="Rounded Rectangle 14"/>
+                <a:latin typeface="Calibri"/>
+              </a:rPr>
+              <a:t>v1: mcq 18 · short_answer 1 · cloze 1</a:t>
+            </a:r>
+          </a:p>
+          <a:p>
+            <a:pPr algn="ctr"/>
+            <a:r>
+              <a:rPr sz="1500" b="0" i="0">
+                <a:solidFill>
+                  <a:srgbClr val="222222"/>
+                </a:solidFill>
+                <a:latin typeface="Calibri"/>
+              </a:rPr>
+              <a:t>v2: mcq 19 · short_answer 1</a:t>
+            </a:r>
+          </a:p>
+          <a:p>
+            <a:pPr algn="ctr"/>
+          </a:p>
+          <a:p>
+            <a:pPr algn="ctr"/>
+            <a:r>
+              <a:rPr sz="1500" b="0" i="0">
+                <a:solidFill>
+                  <a:srgbClr val="222222"/>
+                </a:solidFill>
+                <a:latin typeface="Calibri"/>
+              </a:rPr>
+              <a:t>→ effectively all MCQ</a:t>
+            </a:r>
+          </a:p>
+        </p:txBody>
+      </p:sp>
+      <p:sp>
+        <p:nvSpPr>
+          <p:cNvPr id="14" name="Rounded Rectangle 13"/>
           <p:cNvSpPr/>
           <p:nvPr/>
         </p:nvSpPr>
         <p:spPr>
           <a:xfrm>
-            <a:off x="6400800" y="1645920"/>
-            <a:ext cx="2560320" cy="822960"/>
+            <a:off x="6400800" y="2286000"/>
+            <a:ext cx="5212080" cy="548640"/>
           </a:xfrm>
           <a:prstGeom prst="roundRect">
+            <a:avLst/>
+          </a:prstGeom>
+          <a:solidFill>
+            <a:srgbClr val="31A354"/>
+          </a:solidFill>
+          <a:ln w="15875">
+            <a:solidFill>
+              <a:srgbClr val="31A354"/>
+            </a:solidFill>
+          </a:ln>
+          <a:effectLst/>
+        </p:spPr>
+        <p:style>
+          <a:lnRef idx="1">
+            <a:schemeClr val="accent1"/>
+          </a:lnRef>
+          <a:fillRef idx="3">
+            <a:schemeClr val="accent1"/>
+          </a:fillRef>
+          <a:effectRef idx="2">
+            <a:schemeClr val="accent1"/>
+          </a:effectRef>
+          <a:fontRef idx="minor">
+            <a:schemeClr val="lt1"/>
+          </a:fontRef>
+        </p:style>
+        <p:txBody>
+          <a:bodyPr rtlCol="0" anchor="ctr" wrap="square" lIns="45720" rIns="45720" tIns="27432" bIns="27432"/>
+          <a:lstStyle/>
+          <a:p>
+            <a:pPr algn="ctr"/>
+            <a:r>
+              <a:rPr sz="1500" b="1" i="0">
+                <a:solidFill>
+                  <a:srgbClr val="FFFFFF"/>
+                </a:solidFill>
+                <a:latin typeface="Calibri"/>
+              </a:rPr>
+              <a:t>With qtype_mix (0.4/0.2/0.2/0.2)</a:t>
+            </a:r>
+          </a:p>
+        </p:txBody>
+      </p:sp>
+      <p:sp>
+        <p:nvSpPr>
+          <p:cNvPr id="15" name="Rectangle 14"/>
+          <p:cNvSpPr/>
+          <p:nvPr/>
+        </p:nvSpPr>
+        <p:spPr>
+          <a:xfrm>
+            <a:off x="6400800" y="2926080"/>
+            <a:ext cx="5212080" cy="1463040"/>
+          </a:xfrm>
+          <a:prstGeom prst="rect">
             <a:avLst/>
           </a:prstGeom>
           <a:solidFill>
@@ -10509,204 +11818,54 @@
           <a:p>
             <a:pPr algn="ctr"/>
             <a:r>
-              <a:rPr sz="1200" b="1" i="0">
+              <a:rPr sz="1500" b="0" i="0">
                 <a:solidFill>
                   <a:srgbClr val="222222"/>
                 </a:solidFill>
                 <a:latin typeface="Calibri"/>
               </a:rPr>
-              <a:t>Schema validity</a:t>
-            </a:r>
-          </a:p>
-        </p:txBody>
-      </p:sp>
-      <p:sp>
-        <p:nvSpPr>
-          <p:cNvPr id="16" name="Rounded Rectangle 15"/>
-          <p:cNvSpPr/>
-          <p:nvPr/>
-        </p:nvSpPr>
-        <p:spPr>
-          <a:xfrm>
-            <a:off x="9098280" y="1645920"/>
-            <a:ext cx="2560320" cy="822960"/>
-          </a:xfrm>
-          <a:prstGeom prst="roundRect">
-            <a:avLst/>
-          </a:prstGeom>
-          <a:solidFill>
-            <a:srgbClr val="DEEBF7"/>
-          </a:solidFill>
-          <a:ln w="15875">
-            <a:solidFill>
-              <a:srgbClr val="002F5E"/>
-            </a:solidFill>
-          </a:ln>
-          <a:effectLst/>
-        </p:spPr>
-        <p:style>
-          <a:lnRef idx="1">
-            <a:schemeClr val="accent1"/>
-          </a:lnRef>
-          <a:fillRef idx="3">
-            <a:schemeClr val="accent1"/>
-          </a:fillRef>
-          <a:effectRef idx="2">
-            <a:schemeClr val="accent1"/>
-          </a:effectRef>
-          <a:fontRef idx="minor">
-            <a:schemeClr val="lt1"/>
-          </a:fontRef>
-        </p:style>
-        <p:txBody>
-          <a:bodyPr rtlCol="0" anchor="ctr" wrap="square" lIns="45720" rIns="45720" tIns="27432" bIns="27432"/>
-          <a:lstStyle/>
-          <a:p>
-            <a:pPr algn="ctr"/>
-            <a:r>
-              <a:rPr sz="1200" b="1" i="0">
+              <a:t>v1: mcq 8 · true_false 4 · short_answer 4 · cloze 4</a:t>
+            </a:r>
+          </a:p>
+          <a:p>
+            <a:pPr algn="ctr"/>
+            <a:r>
+              <a:rPr sz="1500" b="0" i="0">
                 <a:solidFill>
                   <a:srgbClr val="222222"/>
                 </a:solidFill>
                 <a:latin typeface="Calibri"/>
               </a:rPr>
-              <a:t>Blueprint compliance</a:t>
-            </a:r>
-          </a:p>
-          <a:p>
-            <a:pPr algn="ctr"/>
-            <a:r>
-              <a:rPr sz="1200" b="1" i="0">
+              <a:t>v2: mcq 8 · true_false 4 · short_answer 4 · cloze 4</a:t>
+            </a:r>
+          </a:p>
+          <a:p>
+            <a:pPr algn="ctr"/>
+          </a:p>
+          <a:p>
+            <a:pPr algn="ctr"/>
+            <a:r>
+              <a:rPr sz="1500" b="0" i="0">
                 <a:solidFill>
                   <a:srgbClr val="222222"/>
                 </a:solidFill>
                 <a:latin typeface="Calibri"/>
               </a:rPr>
-              <a:t>(chapter · difficulty · type)</a:t>
-            </a:r>
-          </a:p>
-        </p:txBody>
-      </p:sp>
-      <p:sp>
-        <p:nvSpPr>
-          <p:cNvPr id="17" name="Rounded Rectangle 16"/>
-          <p:cNvSpPr/>
-          <p:nvPr/>
-        </p:nvSpPr>
-        <p:spPr>
-          <a:xfrm>
-            <a:off x="6400800" y="2606040"/>
-            <a:ext cx="2560320" cy="822960"/>
-          </a:xfrm>
-          <a:prstGeom prst="roundRect">
-            <a:avLst/>
-          </a:prstGeom>
-          <a:solidFill>
-            <a:srgbClr val="E5F5E0"/>
-          </a:solidFill>
-          <a:ln w="15875">
-            <a:solidFill>
-              <a:srgbClr val="31A354"/>
-            </a:solidFill>
-          </a:ln>
-          <a:effectLst/>
-        </p:spPr>
-        <p:style>
-          <a:lnRef idx="1">
-            <a:schemeClr val="accent1"/>
-          </a:lnRef>
-          <a:fillRef idx="3">
-            <a:schemeClr val="accent1"/>
-          </a:fillRef>
-          <a:effectRef idx="2">
-            <a:schemeClr val="accent1"/>
-          </a:effectRef>
-          <a:fontRef idx="minor">
-            <a:schemeClr val="lt1"/>
-          </a:fontRef>
-        </p:style>
-        <p:txBody>
-          <a:bodyPr rtlCol="0" anchor="ctr" wrap="square" lIns="45720" rIns="45720" tIns="27432" bIns="27432"/>
-          <a:lstStyle/>
-          <a:p>
-            <a:pPr algn="ctr"/>
-            <a:r>
-              <a:rPr sz="1200" b="1" i="0">
-                <a:solidFill>
-                  <a:srgbClr val="222222"/>
-                </a:solidFill>
-                <a:latin typeface="Calibri"/>
-              </a:rPr>
-              <a:t>Grounding coverage</a:t>
-            </a:r>
-          </a:p>
-        </p:txBody>
-      </p:sp>
-      <p:sp>
-        <p:nvSpPr>
-          <p:cNvPr id="18" name="Rounded Rectangle 17"/>
-          <p:cNvSpPr/>
-          <p:nvPr/>
-        </p:nvSpPr>
-        <p:spPr>
-          <a:xfrm>
-            <a:off x="9098280" y="2606040"/>
-            <a:ext cx="2560320" cy="822960"/>
-          </a:xfrm>
-          <a:prstGeom prst="roundRect">
-            <a:avLst/>
-          </a:prstGeom>
-          <a:solidFill>
-            <a:srgbClr val="DEEBF7"/>
-          </a:solidFill>
-          <a:ln w="15875">
-            <a:solidFill>
-              <a:srgbClr val="002F5E"/>
-            </a:solidFill>
-          </a:ln>
-          <a:effectLst/>
-        </p:spPr>
-        <p:style>
-          <a:lnRef idx="1">
-            <a:schemeClr val="accent1"/>
-          </a:lnRef>
-          <a:fillRef idx="3">
-            <a:schemeClr val="accent1"/>
-          </a:fillRef>
-          <a:effectRef idx="2">
-            <a:schemeClr val="accent1"/>
-          </a:effectRef>
-          <a:fontRef idx="minor">
-            <a:schemeClr val="lt1"/>
-          </a:fontRef>
-        </p:style>
-        <p:txBody>
-          <a:bodyPr rtlCol="0" anchor="ctr" wrap="square" lIns="45720" rIns="45720" tIns="27432" bIns="27432"/>
-          <a:lstStyle/>
-          <a:p>
-            <a:pPr algn="ctr"/>
-            <a:r>
-              <a:rPr sz="1200" b="1" i="0">
-                <a:solidFill>
-                  <a:srgbClr val="222222"/>
-                </a:solidFill>
-                <a:latin typeface="Calibri"/>
-              </a:rPr>
-              <a:t>Duplicate rate</a:t>
-            </a:r>
-          </a:p>
-        </p:txBody>
-      </p:sp>
-      <p:sp>
-        <p:nvSpPr>
-          <p:cNvPr id="19" name="TextBox 18"/>
+              <a:t>→ exact, balanced, still optimal</a:t>
+            </a:r>
+          </a:p>
+        </p:txBody>
+      </p:sp>
+      <p:sp>
+        <p:nvSpPr>
+          <p:cNvPr id="16" name="TextBox 15"/>
           <p:cNvSpPr txBox="1"/>
           <p:nvPr/>
         </p:nvSpPr>
         <p:spPr>
           <a:xfrm>
-            <a:off x="6400800" y="3703320"/>
-            <a:ext cx="5303520" cy="1463040"/>
+            <a:off x="640080" y="4846320"/>
+            <a:ext cx="10972800" cy="1280160"/>
           </a:xfrm>
           <a:prstGeom prst="rect">
             <a:avLst/>
@@ -10721,13 +11880,13 @@
           <a:p>
             <a:pPr algn="l"/>
             <a:r>
-              <a:rPr sz="1400" b="0" i="1">
+              <a:rPr sz="1600" b="0" i="1">
                 <a:solidFill>
                   <a:srgbClr val="636363"/>
                 </a:solidFill>
                 <a:latin typeface="Calibri"/>
               </a:rPr>
-              <a:t>Overall PASS only if no schema-invalid items and (if checked) the blueprint matches exactly. Exit code feeds CI.</a:t>
+              <a:t>The fix is a constraint, not a hack: qtype_mix is the question-type analogue of difficulty_mix, resolved to exact counts (largest-remainder) and enforced per version by both selectors. Pool stays mixed; the mix becomes guaranteed.</a:t>
             </a:r>
           </a:p>
         </p:txBody>
@@ -10868,7 +12027,7 @@
                 </a:solidFill>
                 <a:latin typeface="Calibri"/>
               </a:rPr>
-              <a:t>Using it</a:t>
+              <a:t>Deduplication &amp; validation</a:t>
             </a:r>
           </a:p>
         </p:txBody>
@@ -10938,7 +12097,7 @@
                 </a:solidFill>
                 <a:latin typeface="Calibri"/>
               </a:rPr>
-              <a:t>python -m quizgen</a:t>
+              <a:t>similarity.py • dedup.py • validate.py</a:t>
             </a:r>
           </a:p>
         </p:txBody>
@@ -11100,8 +12259,8 @@
         </p:nvSpPr>
         <p:spPr>
           <a:xfrm>
-            <a:off x="640080" y="1188720"/>
-            <a:ext cx="10972800" cy="365760"/>
+            <a:off x="640080" y="1143000"/>
+            <a:ext cx="5486400" cy="365760"/>
           </a:xfrm>
           <a:prstGeom prst="rect">
             <a:avLst/>
@@ -11116,33 +12275,249 @@
           <a:p>
             <a:pPr algn="l"/>
             <a:r>
-              <a:rPr sz="1600" b="1" i="0">
+              <a:rPr sz="1700" b="1" i="0">
+                <a:solidFill>
+                  <a:srgbClr val="002F5E"/>
+                </a:solidFill>
+                <a:latin typeface="Calibri"/>
+              </a:rPr>
+              <a:t>DEDUP (--dedup)</a:t>
+            </a:r>
+          </a:p>
+        </p:txBody>
+      </p:sp>
+      <p:sp>
+        <p:nvSpPr>
+          <p:cNvPr id="12" name="TextBox 11"/>
+          <p:cNvSpPr txBox="1"/>
+          <p:nvPr/>
+        </p:nvSpPr>
+        <p:spPr>
+          <a:xfrm>
+            <a:off x="640080" y="1554480"/>
+            <a:ext cx="5303520" cy="2194560"/>
+          </a:xfrm>
+          <a:prstGeom prst="rect">
+            <a:avLst/>
+          </a:prstGeom>
+          <a:noFill/>
+        </p:spPr>
+        <p:txBody>
+          <a:bodyPr wrap="square">
+            <a:spAutoFit/>
+          </a:bodyPr>
+          <a:lstStyle/>
+          <a:p>
+            <a:pPr>
+              <a:spcAft>
+                <a:spcPts val="700"/>
+              </a:spcAft>
+            </a:pPr>
+            <a:r>
+              <a:rPr sz="1500">
                 <a:solidFill>
                   <a:srgbClr val="222222"/>
                 </a:solidFill>
                 <a:latin typeface="Calibri"/>
               </a:rPr>
-              <a:t>Pure command line (no YAML):</a:t>
-            </a:r>
-          </a:p>
-        </p:txBody>
-      </p:sp>
-      <p:sp>
-        <p:nvSpPr>
-          <p:cNvPr id="12" name="Rectangle 11"/>
+              <a:t>• Token-Jaccard over stem+answer(+options) — offline, always on.</a:t>
+            </a:r>
+          </a:p>
+          <a:p>
+            <a:pPr>
+              <a:spcAft>
+                <a:spcPts val="700"/>
+              </a:spcAft>
+            </a:pPr>
+            <a:r>
+              <a:rPr sz="1500">
+                <a:solidFill>
+                  <a:srgbClr val="222222"/>
+                </a:solidFill>
+                <a:latin typeface="Calibri"/>
+              </a:rPr>
+              <a:t>• Optional embedding cosine — catches paraphrases.</a:t>
+            </a:r>
+          </a:p>
+          <a:p>
+            <a:pPr>
+              <a:spcAft>
+                <a:spcPts val="700"/>
+              </a:spcAft>
+            </a:pPr>
+            <a:r>
+              <a:rPr sz="1500">
+                <a:solidFill>
+                  <a:srgbClr val="222222"/>
+                </a:solidFill>
+                <a:latin typeface="Calibri"/>
+              </a:rPr>
+              <a:t>• Drops dups from the pool; MIP also forbids dup pairs across versions.</a:t>
+            </a:r>
+          </a:p>
+        </p:txBody>
+      </p:sp>
+      <p:sp>
+        <p:nvSpPr>
+          <p:cNvPr id="13" name="Rectangle 12"/>
           <p:cNvSpPr/>
           <p:nvPr/>
         </p:nvSpPr>
         <p:spPr>
           <a:xfrm>
-            <a:off x="640080" y="1600200"/>
-            <a:ext cx="10972800" cy="1371600"/>
+            <a:off x="640080" y="3931920"/>
+            <a:ext cx="5212080" cy="1005840"/>
           </a:xfrm>
           <a:prstGeom prst="rect">
             <a:avLst/>
           </a:prstGeom>
           <a:solidFill>
-            <a:srgbClr val="002F5E"/>
+            <a:srgbClr val="F0F0F2"/>
+          </a:solidFill>
+          <a:ln w="15875">
+            <a:solidFill>
+              <a:srgbClr val="636363"/>
+            </a:solidFill>
+          </a:ln>
+          <a:effectLst/>
+        </p:spPr>
+        <p:style>
+          <a:lnRef idx="1">
+            <a:schemeClr val="accent1"/>
+          </a:lnRef>
+          <a:fillRef idx="3">
+            <a:schemeClr val="accent1"/>
+          </a:fillRef>
+          <a:effectRef idx="2">
+            <a:schemeClr val="accent1"/>
+          </a:effectRef>
+          <a:fontRef idx="minor">
+            <a:schemeClr val="lt1"/>
+          </a:fontRef>
+        </p:style>
+        <p:txBody>
+          <a:bodyPr rtlCol="0" anchor="ctr" wrap="square" lIns="45720" rIns="45720" tIns="27432" bIns="27432"/>
+          <a:lstStyle/>
+          <a:p>
+            <a:pPr algn="ctr"/>
+            <a:r>
+              <a:rPr sz="1400" b="0" i="0">
+                <a:solidFill>
+                  <a:srgbClr val="222222"/>
+                </a:solidFill>
+                <a:latin typeface="Consolas"/>
+              </a:rPr>
+              <a:t>sim(q₁,q₂) = |T(q₁) ∩ T(q₂)| / |T(q₁) ∪ T(q₂)|</a:t>
+            </a:r>
+          </a:p>
+        </p:txBody>
+      </p:sp>
+      <p:sp>
+        <p:nvSpPr>
+          <p:cNvPr id="14" name="TextBox 13"/>
+          <p:cNvSpPr txBox="1"/>
+          <p:nvPr/>
+        </p:nvSpPr>
+        <p:spPr>
+          <a:xfrm>
+            <a:off x="6400800" y="1143000"/>
+            <a:ext cx="5486400" cy="365760"/>
+          </a:xfrm>
+          <a:prstGeom prst="rect">
+            <a:avLst/>
+          </a:prstGeom>
+          <a:noFill/>
+        </p:spPr>
+        <p:txBody>
+          <a:bodyPr wrap="square" anchor="t">
+            <a:spAutoFit/>
+          </a:bodyPr>
+          <a:lstStyle/>
+          <a:p>
+            <a:pPr algn="l"/>
+            <a:r>
+              <a:rPr sz="1700" b="1" i="0">
+                <a:solidFill>
+                  <a:srgbClr val="31A354"/>
+                </a:solidFill>
+                <a:latin typeface="Calibri"/>
+              </a:rPr>
+              <a:t>VALIDATE (--validate)</a:t>
+            </a:r>
+          </a:p>
+        </p:txBody>
+      </p:sp>
+      <p:sp>
+        <p:nvSpPr>
+          <p:cNvPr id="15" name="Rounded Rectangle 14"/>
+          <p:cNvSpPr/>
+          <p:nvPr/>
+        </p:nvSpPr>
+        <p:spPr>
+          <a:xfrm>
+            <a:off x="6400800" y="1645920"/>
+            <a:ext cx="2560320" cy="822960"/>
+          </a:xfrm>
+          <a:prstGeom prst="roundRect">
+            <a:avLst/>
+          </a:prstGeom>
+          <a:solidFill>
+            <a:srgbClr val="E5F5E0"/>
+          </a:solidFill>
+          <a:ln w="15875">
+            <a:solidFill>
+              <a:srgbClr val="31A354"/>
+            </a:solidFill>
+          </a:ln>
+          <a:effectLst/>
+        </p:spPr>
+        <p:style>
+          <a:lnRef idx="1">
+            <a:schemeClr val="accent1"/>
+          </a:lnRef>
+          <a:fillRef idx="3">
+            <a:schemeClr val="accent1"/>
+          </a:fillRef>
+          <a:effectRef idx="2">
+            <a:schemeClr val="accent1"/>
+          </a:effectRef>
+          <a:fontRef idx="minor">
+            <a:schemeClr val="lt1"/>
+          </a:fontRef>
+        </p:style>
+        <p:txBody>
+          <a:bodyPr rtlCol="0" anchor="ctr" wrap="square" lIns="45720" rIns="45720" tIns="27432" bIns="27432"/>
+          <a:lstStyle/>
+          <a:p>
+            <a:pPr algn="ctr"/>
+            <a:r>
+              <a:rPr sz="1200" b="1" i="0">
+                <a:solidFill>
+                  <a:srgbClr val="222222"/>
+                </a:solidFill>
+                <a:latin typeface="Calibri"/>
+              </a:rPr>
+              <a:t>Schema validity</a:t>
+            </a:r>
+          </a:p>
+        </p:txBody>
+      </p:sp>
+      <p:sp>
+        <p:nvSpPr>
+          <p:cNvPr id="16" name="Rounded Rectangle 15"/>
+          <p:cNvSpPr/>
+          <p:nvPr/>
+        </p:nvSpPr>
+        <p:spPr>
+          <a:xfrm>
+            <a:off x="9098280" y="1645920"/>
+            <a:ext cx="2560320" cy="822960"/>
+          </a:xfrm>
+          <a:prstGeom prst="roundRect">
+            <a:avLst/>
+          </a:prstGeom>
+          <a:solidFill>
+            <a:srgbClr val="DEEBF7"/>
           </a:solidFill>
           <a:ln w="15875">
             <a:solidFill>
@@ -11171,116 +12546,100 @@
           <a:p>
             <a:pPr algn="ctr"/>
             <a:r>
-              <a:rPr sz="1300" b="0" i="0">
-                <a:solidFill>
-                  <a:srgbClr val="FFFFFF"/>
-                </a:solidFill>
-                <a:latin typeface="Consolas"/>
-              </a:rPr>
-              <a:t>python -m quizgen --pool questions.json \</a:t>
-            </a:r>
-          </a:p>
-          <a:p>
-            <a:pPr algn="ctr"/>
-            <a:r>
-              <a:rPr sz="1300" b="0" i="0">
-                <a:solidFill>
-                  <a:srgbClr val="FFFFFF"/>
-                </a:solidFill>
-                <a:latin typeface="Consolas"/>
-              </a:rPr>
-              <a:t>    --total 20 --chapters 1:10,2:6,3:4 \</a:t>
-            </a:r>
-          </a:p>
-          <a:p>
-            <a:pPr algn="ctr"/>
-            <a:r>
-              <a:rPr sz="1300" b="0" i="0">
-                <a:solidFill>
-                  <a:srgbClr val="FFFFFF"/>
-                </a:solidFill>
-                <a:latin typeface="Consolas"/>
-              </a:rPr>
-              <a:t>    --difficulty 0.4,0.4,0.2 \</a:t>
-            </a:r>
-          </a:p>
-          <a:p>
-            <a:pPr algn="ctr"/>
-            <a:r>
-              <a:rPr sz="1300" b="0" i="0">
-                <a:solidFill>
-                  <a:srgbClr val="FFFFFF"/>
-                </a:solidFill>
-                <a:latin typeface="Consolas"/>
-              </a:rPr>
-              <a:t>    --qtype-mix mcq:0.4,true_false:0.2,short_answer:0.2,cloze:0.2 \</a:t>
-            </a:r>
-          </a:p>
-          <a:p>
-            <a:pPr algn="ctr"/>
-            <a:r>
-              <a:rPr sz="1300" b="0" i="0">
-                <a:solidFill>
-                  <a:srgbClr val="FFFFFF"/>
-                </a:solidFill>
-                <a:latin typeface="Consolas"/>
-              </a:rPr>
-              <a:t>    --versions 2 --selector mip</a:t>
-            </a:r>
-          </a:p>
-        </p:txBody>
-      </p:sp>
-      <p:sp>
-        <p:nvSpPr>
-          <p:cNvPr id="13" name="TextBox 12"/>
-          <p:cNvSpPr txBox="1"/>
-          <p:nvPr/>
-        </p:nvSpPr>
-        <p:spPr>
-          <a:xfrm>
-            <a:off x="640080" y="3246120"/>
-            <a:ext cx="10972800" cy="365760"/>
-          </a:xfrm>
-          <a:prstGeom prst="rect">
-            <a:avLst/>
-          </a:prstGeom>
-          <a:noFill/>
-        </p:spPr>
-        <p:txBody>
-          <a:bodyPr wrap="square" anchor="t">
-            <a:spAutoFit/>
-          </a:bodyPr>
-          <a:lstStyle/>
-          <a:p>
-            <a:pPr algn="l"/>
-            <a:r>
-              <a:rPr sz="1600" b="1" i="0">
+              <a:rPr sz="1200" b="1" i="0">
                 <a:solidFill>
                   <a:srgbClr val="222222"/>
                 </a:solidFill>
                 <a:latin typeface="Calibri"/>
               </a:rPr>
-              <a:t>Blueprint file + dedup + per-version validation report:</a:t>
-            </a:r>
-          </a:p>
-        </p:txBody>
-      </p:sp>
-      <p:sp>
-        <p:nvSpPr>
-          <p:cNvPr id="14" name="Rectangle 13"/>
+              <a:t>Blueprint compliance</a:t>
+            </a:r>
+          </a:p>
+          <a:p>
+            <a:pPr algn="ctr"/>
+            <a:r>
+              <a:rPr sz="1200" b="1" i="0">
+                <a:solidFill>
+                  <a:srgbClr val="222222"/>
+                </a:solidFill>
+                <a:latin typeface="Calibri"/>
+              </a:rPr>
+              <a:t>(chapter · difficulty · type)</a:t>
+            </a:r>
+          </a:p>
+        </p:txBody>
+      </p:sp>
+      <p:sp>
+        <p:nvSpPr>
+          <p:cNvPr id="17" name="Rounded Rectangle 16"/>
           <p:cNvSpPr/>
           <p:nvPr/>
         </p:nvSpPr>
         <p:spPr>
           <a:xfrm>
-            <a:off x="640080" y="3657600"/>
-            <a:ext cx="10972800" cy="914400"/>
-          </a:xfrm>
-          <a:prstGeom prst="rect">
+            <a:off x="6400800" y="2606040"/>
+            <a:ext cx="2560320" cy="822960"/>
+          </a:xfrm>
+          <a:prstGeom prst="roundRect">
             <a:avLst/>
           </a:prstGeom>
           <a:solidFill>
-            <a:srgbClr val="002F5E"/>
+            <a:srgbClr val="E5F5E0"/>
+          </a:solidFill>
+          <a:ln w="15875">
+            <a:solidFill>
+              <a:srgbClr val="31A354"/>
+            </a:solidFill>
+          </a:ln>
+          <a:effectLst/>
+        </p:spPr>
+        <p:style>
+          <a:lnRef idx="1">
+            <a:schemeClr val="accent1"/>
+          </a:lnRef>
+          <a:fillRef idx="3">
+            <a:schemeClr val="accent1"/>
+          </a:fillRef>
+          <a:effectRef idx="2">
+            <a:schemeClr val="accent1"/>
+          </a:effectRef>
+          <a:fontRef idx="minor">
+            <a:schemeClr val="lt1"/>
+          </a:fontRef>
+        </p:style>
+        <p:txBody>
+          <a:bodyPr rtlCol="0" anchor="ctr" wrap="square" lIns="45720" rIns="45720" tIns="27432" bIns="27432"/>
+          <a:lstStyle/>
+          <a:p>
+            <a:pPr algn="ctr"/>
+            <a:r>
+              <a:rPr sz="1200" b="1" i="0">
+                <a:solidFill>
+                  <a:srgbClr val="222222"/>
+                </a:solidFill>
+                <a:latin typeface="Calibri"/>
+              </a:rPr>
+              <a:t>Grounding coverage</a:t>
+            </a:r>
+          </a:p>
+        </p:txBody>
+      </p:sp>
+      <p:sp>
+        <p:nvSpPr>
+          <p:cNvPr id="18" name="Rounded Rectangle 17"/>
+          <p:cNvSpPr/>
+          <p:nvPr/>
+        </p:nvSpPr>
+        <p:spPr>
+          <a:xfrm>
+            <a:off x="9098280" y="2606040"/>
+            <a:ext cx="2560320" cy="822960"/>
+          </a:xfrm>
+          <a:prstGeom prst="roundRect">
+            <a:avLst/>
+          </a:prstGeom>
+          <a:solidFill>
+            <a:srgbClr val="DEEBF7"/>
           </a:solidFill>
           <a:ln w="15875">
             <a:solidFill>
@@ -11309,39 +12668,27 @@
           <a:p>
             <a:pPr algn="ctr"/>
             <a:r>
-              <a:rPr sz="1400" b="0" i="0">
-                <a:solidFill>
-                  <a:srgbClr val="FFFFFF"/>
-                </a:solidFill>
-                <a:latin typeface="Consolas"/>
-              </a:rPr>
-              <a:t>python -m quizgen --pool questions.json --blueprint blueprint.yaml \</a:t>
-            </a:r>
-          </a:p>
-          <a:p>
-            <a:pPr algn="ctr"/>
-            <a:r>
-              <a:rPr sz="1400" b="0" i="0">
-                <a:solidFill>
-                  <a:srgbClr val="FFFFFF"/>
-                </a:solidFill>
-                <a:latin typeface="Consolas"/>
-              </a:rPr>
-              <a:t>    --dedup --validate --out-dir out</a:t>
-            </a:r>
-          </a:p>
-        </p:txBody>
-      </p:sp>
-      <p:sp>
-        <p:nvSpPr>
-          <p:cNvPr id="15" name="TextBox 14"/>
+              <a:rPr sz="1200" b="1" i="0">
+                <a:solidFill>
+                  <a:srgbClr val="222222"/>
+                </a:solidFill>
+                <a:latin typeface="Calibri"/>
+              </a:rPr>
+              <a:t>Duplicate rate</a:t>
+            </a:r>
+          </a:p>
+        </p:txBody>
+      </p:sp>
+      <p:sp>
+        <p:nvSpPr>
+          <p:cNvPr id="19" name="TextBox 18"/>
           <p:cNvSpPr txBox="1"/>
           <p:nvPr/>
         </p:nvSpPr>
         <p:spPr>
           <a:xfrm>
-            <a:off x="640080" y="4846320"/>
-            <a:ext cx="10972800" cy="1645920"/>
+            <a:off x="6400800" y="3703320"/>
+            <a:ext cx="5303520" cy="1463040"/>
           </a:xfrm>
           <a:prstGeom prst="rect">
             <a:avLst/>
@@ -11349,56 +12696,20 @@
           <a:noFill/>
         </p:spPr>
         <p:txBody>
-          <a:bodyPr wrap="square">
+          <a:bodyPr wrap="square" anchor="t">
             <a:spAutoFit/>
           </a:bodyPr>
           <a:lstStyle/>
           <a:p>
-            <a:pPr>
-              <a:spcAft>
-                <a:spcPts val="700"/>
-              </a:spcAft>
-            </a:pPr>
-            <a:r>
-              <a:rPr sz="1500">
-                <a:solidFill>
-                  <a:srgbClr val="222222"/>
-                </a:solidFill>
-                <a:latin typeface="Calibri"/>
-              </a:rPr>
-              <a:t>• Writes one Quiz JSON per version (each embeds the resolved blueprint).</a:t>
-            </a:r>
-          </a:p>
-          <a:p>
-            <a:pPr>
-              <a:spcAft>
-                <a:spcPts val="700"/>
-              </a:spcAft>
-            </a:pPr>
-            <a:r>
-              <a:rPr sz="1500">
-                <a:solidFill>
-                  <a:srgbClr val="222222"/>
-                </a:solidFill>
-                <a:latin typeface="Calibri"/>
-              </a:rPr>
-              <a:t>• Standalone entry points too: python -m quizgen.assemble, python -m quizgen.validate.</a:t>
-            </a:r>
-          </a:p>
-          <a:p>
-            <a:pPr>
-              <a:spcAft>
-                <a:spcPts val="700"/>
-              </a:spcAft>
-            </a:pPr>
-            <a:r>
-              <a:rPr sz="1500">
-                <a:solidFill>
-                  <a:srgbClr val="222222"/>
-                </a:solidFill>
-                <a:latin typeface="Calibri"/>
-              </a:rPr>
-              <a:t>• Exits non-zero on any non-compliant version → composes in scripts &amp; CI.</a:t>
+            <a:pPr algn="l"/>
+            <a:r>
+              <a:rPr sz="1400" b="0" i="1">
+                <a:solidFill>
+                  <a:srgbClr val="636363"/>
+                </a:solidFill>
+                <a:latin typeface="Calibri"/>
+              </a:rPr>
+              <a:t>Overall PASS only if no schema-invalid items and (if checked) the blueprint matches exactly. Exit code feeds CI.</a:t>
             </a:r>
           </a:p>
         </p:txBody>

</xml_diff>